<commit_message>
commit bug fix  - printing pins
</commit_message>
<xml_diff>
--- a/docs/marketing/Introducing Turas v4.pptx
+++ b/docs/marketing/Introducing Turas v4.pptx
@@ -11,15 +11,15 @@
   <p:sldIdLst>
     <p:sldId id="296" r:id="rId3"/>
     <p:sldId id="332" r:id="rId4"/>
-    <p:sldId id="333" r:id="rId5"/>
+    <p:sldId id="347" r:id="rId5"/>
     <p:sldId id="323" r:id="rId6"/>
     <p:sldId id="334" r:id="rId7"/>
     <p:sldId id="325" r:id="rId8"/>
-    <p:sldId id="326" r:id="rId9"/>
-    <p:sldId id="327" r:id="rId10"/>
-    <p:sldId id="328" r:id="rId11"/>
+    <p:sldId id="349" r:id="rId9"/>
+    <p:sldId id="350" r:id="rId10"/>
+    <p:sldId id="352" r:id="rId11"/>
     <p:sldId id="329" r:id="rId12"/>
-    <p:sldId id="330" r:id="rId13"/>
+    <p:sldId id="348" r:id="rId13"/>
     <p:sldId id="336" r:id="rId14"/>
     <p:sldId id="341" r:id="rId15"/>
     <p:sldId id="342" r:id="rId16"/>
@@ -9841,6 +9841,35 @@
       </p:sp>
       <p:sp>
         <p:nvSpPr>
+          <p:cNvPr id="150" name="BA"/>
+          <p:cNvSpPr/>
+          <p:nvPr/>
+        </p:nvSpPr>
+        <p:spPr>
+          <a:xfrm>
+            <a:off x="0" y="6807200"/>
+            <a:ext cx="12192000" cy="50800"/>
+          </a:xfrm>
+          <a:prstGeom prst="rect">
+            <a:avLst/>
+          </a:prstGeom>
+          <a:solidFill>
+            <a:srgbClr val="CC9900"/>
+          </a:solidFill>
+          <a:ln>
+            <a:noFill/>
+          </a:ln>
+        </p:spPr>
+        <p:txBody>
+          <a:bodyPr/>
+          <a:lstStyle/>
+          <a:p>
+            <a:endParaRPr lang="en-GB"/>
+          </a:p>
+        </p:txBody>
+      </p:sp>
+      <p:sp>
+        <p:nvSpPr>
           <p:cNvPr id="106" name="MA"/>
           <p:cNvSpPr/>
           <p:nvPr/>
@@ -9870,18 +9899,18 @@
       </p:sp>
       <p:sp>
         <p:nvSpPr>
-          <p:cNvPr id="110" name="P0"/>
-          <p:cNvSpPr/>
-          <p:nvPr/>
-        </p:nvSpPr>
-        <p:spPr>
-          <a:xfrm>
-            <a:off x="762000" y="1968500"/>
-            <a:ext cx="2590800" cy="2540000"/>
+          <p:cNvPr id="107" name="P0"/>
+          <p:cNvSpPr/>
+          <p:nvPr/>
+        </p:nvSpPr>
+        <p:spPr>
+          <a:xfrm>
+            <a:off x="762000" y="1905000"/>
+            <a:ext cx="3454400" cy="1524000"/>
           </a:xfrm>
           <a:prstGeom prst="roundRect">
             <a:avLst>
-              <a:gd name="adj" fmla="val 6000"/>
+              <a:gd name="adj" fmla="val 3000"/>
             </a:avLst>
           </a:prstGeom>
           <a:solidFill>
@@ -9903,14 +9932,14 @@
       </p:sp>
       <p:sp>
         <p:nvSpPr>
-          <p:cNvPr id="111" name="PTx0"/>
-          <p:cNvSpPr/>
-          <p:nvPr/>
-        </p:nvSpPr>
-        <p:spPr>
-          <a:xfrm>
-            <a:off x="914400" y="2032000"/>
-            <a:ext cx="2286000" cy="2349500"/>
+          <p:cNvPr id="108" name="PTx0"/>
+          <p:cNvSpPr/>
+          <p:nvPr/>
+        </p:nvSpPr>
+        <p:spPr>
+          <a:xfrm>
+            <a:off x="952500" y="2057400"/>
+            <a:ext cx="3073400" cy="1219200"/>
           </a:xfrm>
           <a:prstGeom prst="rect">
             <a:avLst/>
@@ -9921,7 +9950,7 @@
           </a:ln>
         </p:spPr>
         <p:txBody>
-          <a:bodyPr wrap="square" lIns="0" tIns="45720" rIns="0" bIns="0" anchor="t"/>
+          <a:bodyPr wrap="square" lIns="0" tIns="0" rIns="0" bIns="0" anchor="t"/>
           <a:lstStyle/>
           <a:p>
             <a:pPr algn="ctr">
@@ -9942,11 +9971,11 @@
           <a:p>
             <a:pPr algn="ctr">
               <a:spcAft>
-                <a:spcPts val="400"/>
+                <a:spcPts val="300"/>
               </a:spcAft>
             </a:pPr>
             <a:r>
-              <a:rPr lang="en-GB" sz="1800" b="1" dirty="0">
+              <a:rPr lang="en-GB" sz="1600" b="1" dirty="0">
                 <a:solidFill>
                   <a:srgbClr val="1A2744"/>
                 </a:solidFill>
@@ -9958,31 +9987,31 @@
           <a:p>
             <a:pPr algn="ctr"/>
             <a:r>
-              <a:rPr lang="en-GB" sz="1400" dirty="0">
+              <a:rPr lang="en-GB" sz="1200" dirty="0">
                 <a:solidFill>
                   <a:srgbClr val="4A5568"/>
                 </a:solidFill>
                 <a:latin typeface="Source Sans Pro"/>
               </a:rPr>
-              <a:t>Structuring questions to produce clean, analysable data</a:t>
-            </a:r>
-          </a:p>
-        </p:txBody>
-      </p:sp>
-      <p:sp>
-        <p:nvSpPr>
-          <p:cNvPr id="112" name="P1"/>
-          <p:cNvSpPr/>
-          <p:nvPr/>
-        </p:nvSpPr>
-        <p:spPr>
-          <a:xfrm>
-            <a:off x="3581400" y="1968500"/>
-            <a:ext cx="2590800" cy="2540000"/>
+              <a:t>Structuring questions to produce clean, analysable data.</a:t>
+            </a:r>
+          </a:p>
+        </p:txBody>
+      </p:sp>
+      <p:sp>
+        <p:nvSpPr>
+          <p:cNvPr id="109" name="P1"/>
+          <p:cNvSpPr/>
+          <p:nvPr/>
+        </p:nvSpPr>
+        <p:spPr>
+          <a:xfrm>
+            <a:off x="4445000" y="1905000"/>
+            <a:ext cx="3454400" cy="1524000"/>
           </a:xfrm>
           <a:prstGeom prst="roundRect">
             <a:avLst>
-              <a:gd name="adj" fmla="val 6000"/>
+              <a:gd name="adj" fmla="val 3000"/>
             </a:avLst>
           </a:prstGeom>
           <a:solidFill>
@@ -10004,14 +10033,14 @@
       </p:sp>
       <p:sp>
         <p:nvSpPr>
-          <p:cNvPr id="113" name="PTx1"/>
-          <p:cNvSpPr/>
-          <p:nvPr/>
-        </p:nvSpPr>
-        <p:spPr>
-          <a:xfrm>
-            <a:off x="3733800" y="2032000"/>
-            <a:ext cx="2286000" cy="2349500"/>
+          <p:cNvPr id="110" name="PTx1"/>
+          <p:cNvSpPr/>
+          <p:nvPr/>
+        </p:nvSpPr>
+        <p:spPr>
+          <a:xfrm>
+            <a:off x="4635500" y="2057400"/>
+            <a:ext cx="3073400" cy="1219200"/>
           </a:xfrm>
           <a:prstGeom prst="rect">
             <a:avLst/>
@@ -10022,7 +10051,7 @@
           </a:ln>
         </p:spPr>
         <p:txBody>
-          <a:bodyPr wrap="square" lIns="0" tIns="45720" rIns="0" bIns="0" anchor="t"/>
+          <a:bodyPr wrap="square" lIns="0" tIns="0" rIns="0" bIns="0" anchor="t"/>
           <a:lstStyle/>
           <a:p>
             <a:pPr algn="ctr">
@@ -10043,11 +10072,11 @@
           <a:p>
             <a:pPr algn="ctr">
               <a:spcAft>
-                <a:spcPts val="400"/>
+                <a:spcPts val="300"/>
               </a:spcAft>
             </a:pPr>
             <a:r>
-              <a:rPr lang="en-GB" sz="1800" b="1" dirty="0">
+              <a:rPr lang="en-GB" sz="1600" b="1" dirty="0">
                 <a:solidFill>
                   <a:srgbClr val="1A2744"/>
                 </a:solidFill>
@@ -10059,31 +10088,31 @@
           <a:p>
             <a:pPr algn="ctr"/>
             <a:r>
-              <a:rPr lang="en-GB" sz="1400" dirty="0">
+              <a:rPr lang="en-GB" sz="1200" dirty="0">
                 <a:solidFill>
                   <a:srgbClr val="4A5568"/>
                 </a:solidFill>
                 <a:latin typeface="Source Sans Pro"/>
               </a:rPr>
-              <a:t>Choosing the right methods and structuring the approach</a:t>
-            </a:r>
-          </a:p>
-        </p:txBody>
-      </p:sp>
-      <p:sp>
-        <p:nvSpPr>
-          <p:cNvPr id="114" name="P2"/>
-          <p:cNvSpPr/>
-          <p:nvPr/>
-        </p:nvSpPr>
-        <p:spPr>
-          <a:xfrm>
-            <a:off x="6400800" y="1968500"/>
-            <a:ext cx="2590800" cy="2540000"/>
+              <a:t>Choosing the right methods and structuring the approach.</a:t>
+            </a:r>
+          </a:p>
+        </p:txBody>
+      </p:sp>
+      <p:sp>
+        <p:nvSpPr>
+          <p:cNvPr id="111" name="P2"/>
+          <p:cNvSpPr/>
+          <p:nvPr/>
+        </p:nvSpPr>
+        <p:spPr>
+          <a:xfrm>
+            <a:off x="8128000" y="1905000"/>
+            <a:ext cx="3454400" cy="1524000"/>
           </a:xfrm>
           <a:prstGeom prst="roundRect">
             <a:avLst>
-              <a:gd name="adj" fmla="val 6000"/>
+              <a:gd name="adj" fmla="val 3000"/>
             </a:avLst>
           </a:prstGeom>
           <a:solidFill>
@@ -10105,14 +10134,14 @@
       </p:sp>
       <p:sp>
         <p:nvSpPr>
-          <p:cNvPr id="115" name="PTx2"/>
-          <p:cNvSpPr/>
-          <p:nvPr/>
-        </p:nvSpPr>
-        <p:spPr>
-          <a:xfrm>
-            <a:off x="6553200" y="2032000"/>
-            <a:ext cx="2286000" cy="2349500"/>
+          <p:cNvPr id="112" name="PTx2"/>
+          <p:cNvSpPr/>
+          <p:nvPr/>
+        </p:nvSpPr>
+        <p:spPr>
+          <a:xfrm>
+            <a:off x="8318500" y="2057400"/>
+            <a:ext cx="3073400" cy="1219200"/>
           </a:xfrm>
           <a:prstGeom prst="rect">
             <a:avLst/>
@@ -10123,7 +10152,7 @@
           </a:ln>
         </p:spPr>
         <p:txBody>
-          <a:bodyPr wrap="square" lIns="0" tIns="45720" rIns="0" bIns="0" anchor="t"/>
+          <a:bodyPr wrap="square" lIns="0" tIns="0" rIns="0" bIns="0" anchor="t"/>
           <a:lstStyle/>
           <a:p>
             <a:pPr algn="ctr">
@@ -10144,11 +10173,11 @@
           <a:p>
             <a:pPr algn="ctr">
               <a:spcAft>
-                <a:spcPts val="400"/>
+                <a:spcPts val="300"/>
               </a:spcAft>
             </a:pPr>
             <a:r>
-              <a:rPr lang="en-GB" sz="1800" b="1" dirty="0">
+              <a:rPr lang="en-GB" sz="1600" b="1" dirty="0">
                 <a:solidFill>
                   <a:srgbClr val="1A2744"/>
                 </a:solidFill>
@@ -10160,31 +10189,31 @@
           <a:p>
             <a:pPr algn="ctr"/>
             <a:r>
-              <a:rPr lang="en-GB" sz="1400" dirty="0">
+              <a:rPr lang="en-GB" sz="1200" dirty="0">
                 <a:solidFill>
                   <a:srgbClr val="4A5568"/>
                 </a:solidFill>
                 <a:latin typeface="Source Sans Pro"/>
               </a:rPr>
-              <a:t>Cleaning, coding, and preparing data for rigorous analysis</a:t>
-            </a:r>
-          </a:p>
-        </p:txBody>
-      </p:sp>
-      <p:sp>
-        <p:nvSpPr>
-          <p:cNvPr id="116" name="P3"/>
-          <p:cNvSpPr/>
-          <p:nvPr/>
-        </p:nvSpPr>
-        <p:spPr>
-          <a:xfrm>
-            <a:off x="9220200" y="1968500"/>
-            <a:ext cx="2590800" cy="2540000"/>
+              <a:t>Cleaning, coding, and preparing data for rigorous analysis.</a:t>
+            </a:r>
+          </a:p>
+        </p:txBody>
+      </p:sp>
+      <p:sp>
+        <p:nvSpPr>
+          <p:cNvPr id="113" name="P3"/>
+          <p:cNvSpPr/>
+          <p:nvPr/>
+        </p:nvSpPr>
+        <p:spPr>
+          <a:xfrm>
+            <a:off x="762000" y="3619500"/>
+            <a:ext cx="5334000" cy="1524000"/>
           </a:xfrm>
           <a:prstGeom prst="roundRect">
             <a:avLst>
-              <a:gd name="adj" fmla="val 6000"/>
+              <a:gd name="adj" fmla="val 3000"/>
             </a:avLst>
           </a:prstGeom>
           <a:solidFill>
@@ -10206,14 +10235,14 @@
       </p:sp>
       <p:sp>
         <p:nvSpPr>
-          <p:cNvPr id="117" name="PTx3"/>
-          <p:cNvSpPr/>
-          <p:nvPr/>
-        </p:nvSpPr>
-        <p:spPr>
-          <a:xfrm>
-            <a:off x="9372600" y="2032000"/>
-            <a:ext cx="2286000" cy="2349500"/>
+          <p:cNvPr id="114" name="PTx3"/>
+          <p:cNvSpPr/>
+          <p:nvPr/>
+        </p:nvSpPr>
+        <p:spPr>
+          <a:xfrm>
+            <a:off x="952500" y="3771900"/>
+            <a:ext cx="4953000" cy="1219200"/>
           </a:xfrm>
           <a:prstGeom prst="rect">
             <a:avLst/>
@@ -10224,7 +10253,7 @@
           </a:ln>
         </p:spPr>
         <p:txBody>
-          <a:bodyPr wrap="square" lIns="0" tIns="45720" rIns="0" bIns="0" anchor="t"/>
+          <a:bodyPr wrap="square" lIns="0" tIns="0" rIns="0" bIns="0" anchor="t"/>
           <a:lstStyle/>
           <a:p>
             <a:pPr algn="ctr">
@@ -10235,7 +10264,7 @@
             <a:r>
               <a:rPr lang="en-GB" sz="1400" dirty="0">
                 <a:solidFill>
-                  <a:srgbClr val="FFB020"/>
+                  <a:srgbClr val="E56B33"/>
                 </a:solidFill>
                 <a:latin typeface="Raleway"/>
               </a:rPr>
@@ -10245,11 +10274,11 @@
           <a:p>
             <a:pPr algn="ctr">
               <a:spcAft>
-                <a:spcPts val="400"/>
+                <a:spcPts val="300"/>
               </a:spcAft>
             </a:pPr>
             <a:r>
-              <a:rPr lang="en-GB" sz="1800" b="1" dirty="0">
+              <a:rPr lang="en-GB" sz="1600" b="1" dirty="0">
                 <a:solidFill>
                   <a:srgbClr val="1A2744"/>
                 </a:solidFill>
@@ -10261,34 +10290,135 @@
           <a:p>
             <a:pPr algn="ctr"/>
             <a:r>
-              <a:rPr lang="en-GB" sz="1400" dirty="0">
+              <a:rPr lang="en-GB" sz="1200" dirty="0">
                 <a:solidFill>
                   <a:srgbClr val="4A5568"/>
                 </a:solidFill>
                 <a:latin typeface="Source Sans Pro"/>
               </a:rPr>
-              <a:t>Making sense of results and building a clear narrative</a:t>
-            </a:r>
-          </a:p>
-        </p:txBody>
-      </p:sp>
-      <p:sp>
-        <p:nvSpPr>
-          <p:cNvPr id="140" name="Call"/>
-          <p:cNvSpPr/>
-          <p:nvPr/>
-        </p:nvSpPr>
-        <p:spPr>
-          <a:xfrm>
-            <a:off x="762000" y="4953000"/>
-            <a:ext cx="10668000" cy="1143000"/>
+              <a:t>Making sense of results and building a clear narrative.</a:t>
+            </a:r>
+          </a:p>
+        </p:txBody>
+      </p:sp>
+      <p:sp>
+        <p:nvSpPr>
+          <p:cNvPr id="115" name="P4"/>
+          <p:cNvSpPr/>
+          <p:nvPr/>
+        </p:nvSpPr>
+        <p:spPr>
+          <a:xfrm>
+            <a:off x="6350000" y="3619500"/>
+            <a:ext cx="5334000" cy="1524000"/>
           </a:xfrm>
           <a:prstGeom prst="roundRect">
             <a:avLst>
-              <a:gd name="adj" fmla="val 10000"/>
+              <a:gd name="adj" fmla="val 3000"/>
             </a:avLst>
           </a:prstGeom>
           <a:solidFill>
+            <a:srgbClr val="F5F7FA"/>
+          </a:solidFill>
+          <a:ln w="6350">
+            <a:solidFill>
+              <a:srgbClr val="E2E8F0"/>
+            </a:solidFill>
+          </a:ln>
+        </p:spPr>
+        <p:txBody>
+          <a:bodyPr/>
+          <a:lstStyle/>
+          <a:p>
+            <a:endParaRPr lang="en-GB"/>
+          </a:p>
+        </p:txBody>
+      </p:sp>
+      <p:sp>
+        <p:nvSpPr>
+          <p:cNvPr id="116" name="PTx4"/>
+          <p:cNvSpPr/>
+          <p:nvPr/>
+        </p:nvSpPr>
+        <p:spPr>
+          <a:xfrm>
+            <a:off x="6540500" y="3771900"/>
+            <a:ext cx="4953000" cy="1219200"/>
+          </a:xfrm>
+          <a:prstGeom prst="rect">
+            <a:avLst/>
+          </a:prstGeom>
+          <a:noFill/>
+          <a:ln>
+            <a:noFill/>
+          </a:ln>
+        </p:spPr>
+        <p:txBody>
+          <a:bodyPr wrap="square" lIns="0" tIns="0" rIns="0" bIns="0" anchor="t"/>
+          <a:lstStyle/>
+          <a:p>
+            <a:pPr algn="ctr">
+              <a:spcAft>
+                <a:spcPts val="200"/>
+              </a:spcAft>
+            </a:pPr>
+            <a:r>
+              <a:rPr lang="en-GB" sz="1400" dirty="0">
+                <a:solidFill>
+                  <a:srgbClr val="CC9900"/>
+                </a:solidFill>
+                <a:latin typeface="Raleway"/>
+              </a:rPr>
+              <a:t>━━━</a:t>
+            </a:r>
+          </a:p>
+          <a:p>
+            <a:pPr algn="ctr">
+              <a:spcAft>
+                <a:spcPts val="300"/>
+              </a:spcAft>
+            </a:pPr>
+            <a:r>
+              <a:rPr lang="en-GB" sz="1600" b="1" dirty="0">
+                <a:solidFill>
+                  <a:srgbClr val="1A2744"/>
+                </a:solidFill>
+                <a:latin typeface="Raleway"/>
+              </a:rPr>
+              <a:t>Third-Party Data</a:t>
+            </a:r>
+          </a:p>
+          <a:p>
+            <a:pPr algn="ctr"/>
+            <a:r>
+              <a:rPr lang="en-GB" sz="1200" dirty="0">
+                <a:solidFill>
+                  <a:srgbClr val="4A5568"/>
+                </a:solidFill>
+                <a:latin typeface="Source Sans Pro"/>
+              </a:rPr>
+              <a:t>We can evaluate and prepare existing datasets for analysis, regardless of source.</a:t>
+            </a:r>
+          </a:p>
+        </p:txBody>
+      </p:sp>
+      <p:sp>
+        <p:nvSpPr>
+          <p:cNvPr id="117" name="Call"/>
+          <p:cNvSpPr/>
+          <p:nvPr/>
+        </p:nvSpPr>
+        <p:spPr>
+          <a:xfrm>
+            <a:off x="762000" y="5334000"/>
+            <a:ext cx="10668000" cy="698500"/>
+          </a:xfrm>
+          <a:prstGeom prst="roundRect">
+            <a:avLst>
+              <a:gd name="adj" fmla="val 8000"/>
+            </a:avLst>
+          </a:prstGeom>
+          <a:solidFill>
             <a:srgbClr val="323367"/>
           </a:solidFill>
           <a:ln>
@@ -10296,12 +10426,12 @@
           </a:ln>
         </p:spPr>
         <p:txBody>
-          <a:bodyPr wrap="square" lIns="182880" tIns="45720" rIns="182880" bIns="45720" anchor="ctr"/>
+          <a:bodyPr wrap="square" lIns="72000" tIns="36000" rIns="72000" bIns="36000" anchor="ctr"/>
           <a:lstStyle/>
           <a:p>
             <a:pPr algn="ctr"/>
             <a:r>
-              <a:rPr lang="en-GB" sz="1600" i="1" dirty="0">
+              <a:rPr lang="en-GB" sz="1400" i="1" dirty="0">
                 <a:solidFill>
                   <a:srgbClr val="CC9900"/>
                 </a:solidFill>
@@ -10309,42 +10439,13 @@
               </a:rPr>
               <a:t>For most projects we also prepare an initial set of pinned views, giving your team a ready-made starting point.</a:t>
             </a:r>
-          </a:p>
-        </p:txBody>
-      </p:sp>
-      <p:sp>
-        <p:nvSpPr>
-          <p:cNvPr id="150" name="BA"/>
-          <p:cNvSpPr/>
-          <p:nvPr/>
-        </p:nvSpPr>
-        <p:spPr>
-          <a:xfrm>
-            <a:off x="0" y="6807200"/>
-            <a:ext cx="12192000" cy="50800"/>
-          </a:xfrm>
-          <a:prstGeom prst="rect">
-            <a:avLst/>
-          </a:prstGeom>
-          <a:solidFill>
-            <a:srgbClr val="CC9900"/>
-          </a:solidFill>
-          <a:ln>
-            <a:noFill/>
-          </a:ln>
-        </p:spPr>
-        <p:txBody>
-          <a:bodyPr/>
-          <a:lstStyle/>
-          <a:p>
-            <a:endParaRPr lang="en-GB"/>
           </a:p>
         </p:txBody>
       </p:sp>
     </p:spTree>
     <p:extLst>
       <p:ext uri="{BB962C8B-B14F-4D97-AF65-F5344CB8AC3E}">
-        <p14:creationId xmlns:p14="http://schemas.microsoft.com/office/powerpoint/2010/main" val="2025322948"/>
+        <p14:creationId xmlns:p14="http://schemas.microsoft.com/office/powerpoint/2010/main" val="1591960344"/>
       </p:ext>
     </p:extLst>
   </p:cSld>
@@ -13995,6 +14096,35 @@
       </p:sp>
       <p:sp>
         <p:nvSpPr>
+          <p:cNvPr id="150" name="BA"/>
+          <p:cNvSpPr/>
+          <p:nvPr/>
+        </p:nvSpPr>
+        <p:spPr>
+          <a:xfrm>
+            <a:off x="0" y="6807200"/>
+            <a:ext cx="12192000" cy="50800"/>
+          </a:xfrm>
+          <a:prstGeom prst="rect">
+            <a:avLst/>
+          </a:prstGeom>
+          <a:solidFill>
+            <a:srgbClr val="CC9900"/>
+          </a:solidFill>
+          <a:ln>
+            <a:noFill/>
+          </a:ln>
+        </p:spPr>
+        <p:txBody>
+          <a:bodyPr/>
+          <a:lstStyle/>
+          <a:p>
+            <a:endParaRPr lang="en-GB"/>
+          </a:p>
+        </p:txBody>
+      </p:sp>
+      <p:sp>
+        <p:nvSpPr>
           <p:cNvPr id="106" name="MA"/>
           <p:cNvSpPr/>
           <p:nvPr/>
@@ -14024,18 +14154,18 @@
       </p:sp>
       <p:sp>
         <p:nvSpPr>
-          <p:cNvPr id="110" name="F0"/>
-          <p:cNvSpPr/>
-          <p:nvPr/>
-        </p:nvSpPr>
-        <p:spPr>
-          <a:xfrm>
-            <a:off x="762000" y="1905000"/>
-            <a:ext cx="5334000" cy="1333500"/>
+          <p:cNvPr id="107" name="F0"/>
+          <p:cNvSpPr/>
+          <p:nvPr/>
+        </p:nvSpPr>
+        <p:spPr>
+          <a:xfrm>
+            <a:off x="762000" y="1879600"/>
+            <a:ext cx="3454400" cy="1143000"/>
           </a:xfrm>
           <a:prstGeom prst="roundRect">
             <a:avLst>
-              <a:gd name="adj" fmla="val 6000"/>
+              <a:gd name="adj" fmla="val 3000"/>
             </a:avLst>
           </a:prstGeom>
           <a:solidFill>
@@ -14057,14 +14187,14 @@
       </p:sp>
       <p:sp>
         <p:nvSpPr>
-          <p:cNvPr id="111" name="FA0"/>
-          <p:cNvSpPr/>
-          <p:nvPr/>
-        </p:nvSpPr>
-        <p:spPr>
-          <a:xfrm>
-            <a:off x="914400" y="1905000"/>
-            <a:ext cx="635000" cy="38100"/>
+          <p:cNvPr id="108" name="FA0"/>
+          <p:cNvSpPr/>
+          <p:nvPr/>
+        </p:nvSpPr>
+        <p:spPr>
+          <a:xfrm>
+            <a:off x="914400" y="1879600"/>
+            <a:ext cx="508000" cy="38100"/>
           </a:xfrm>
           <a:prstGeom prst="rect">
             <a:avLst/>
@@ -14086,14 +14216,14 @@
       </p:sp>
       <p:sp>
         <p:nvSpPr>
-          <p:cNvPr id="112" name="FT0"/>
-          <p:cNvSpPr/>
-          <p:nvPr/>
-        </p:nvSpPr>
-        <p:spPr>
-          <a:xfrm>
-            <a:off x="952500" y="2095500"/>
-            <a:ext cx="4953000" cy="1016000"/>
+          <p:cNvPr id="109" name="FT0"/>
+          <p:cNvSpPr/>
+          <p:nvPr/>
+        </p:nvSpPr>
+        <p:spPr>
+          <a:xfrm>
+            <a:off x="914400" y="2032000"/>
+            <a:ext cx="3149600" cy="889000"/>
           </a:xfrm>
           <a:prstGeom prst="rect">
             <a:avLst/>
@@ -14109,11 +14239,11 @@
           <a:p>
             <a:pPr algn="l">
               <a:spcAft>
-                <a:spcPts val="300"/>
+                <a:spcPts val="200"/>
               </a:spcAft>
             </a:pPr>
             <a:r>
-              <a:rPr lang="en-GB" sz="1800" b="1" dirty="0">
+              <a:rPr lang="en-GB" sz="1600" b="1" dirty="0">
                 <a:solidFill>
                   <a:srgbClr val="1A2744"/>
                 </a:solidFill>
@@ -14125,31 +14255,31 @@
           <a:p>
             <a:pPr algn="l"/>
             <a:r>
-              <a:rPr lang="en-GB" sz="1400" dirty="0">
+              <a:rPr lang="en-GB" sz="1200" dirty="0">
                 <a:solidFill>
                   <a:srgbClr val="4A5568"/>
                 </a:solidFill>
                 <a:latin typeface="Source Sans Pro"/>
               </a:rPr>
-              <a:t>An interactive resource your team can explore, share, and return to</a:t>
-            </a:r>
-          </a:p>
-        </p:txBody>
-      </p:sp>
-      <p:sp>
-        <p:nvSpPr>
-          <p:cNvPr id="113" name="F1"/>
-          <p:cNvSpPr/>
-          <p:nvPr/>
-        </p:nvSpPr>
-        <p:spPr>
-          <a:xfrm>
-            <a:off x="6350000" y="1905000"/>
-            <a:ext cx="5334000" cy="1333500"/>
+              <a:t>An interactive resource your team can explore, share, and return to.</a:t>
+            </a:r>
+          </a:p>
+        </p:txBody>
+      </p:sp>
+      <p:sp>
+        <p:nvSpPr>
+          <p:cNvPr id="110" name="F1"/>
+          <p:cNvSpPr/>
+          <p:nvPr/>
+        </p:nvSpPr>
+        <p:spPr>
+          <a:xfrm>
+            <a:off x="4445000" y="1879600"/>
+            <a:ext cx="3454400" cy="1143000"/>
           </a:xfrm>
           <a:prstGeom prst="roundRect">
             <a:avLst>
-              <a:gd name="adj" fmla="val 6000"/>
+              <a:gd name="adj" fmla="val 3000"/>
             </a:avLst>
           </a:prstGeom>
           <a:solidFill>
@@ -14171,14 +14301,14 @@
       </p:sp>
       <p:sp>
         <p:nvSpPr>
-          <p:cNvPr id="114" name="FA1"/>
-          <p:cNvSpPr/>
-          <p:nvPr/>
-        </p:nvSpPr>
-        <p:spPr>
-          <a:xfrm>
-            <a:off x="6502400" y="1905000"/>
-            <a:ext cx="635000" cy="38100"/>
+          <p:cNvPr id="111" name="FA1"/>
+          <p:cNvSpPr/>
+          <p:nvPr/>
+        </p:nvSpPr>
+        <p:spPr>
+          <a:xfrm>
+            <a:off x="4597400" y="1879600"/>
+            <a:ext cx="508000" cy="38100"/>
           </a:xfrm>
           <a:prstGeom prst="rect">
             <a:avLst/>
@@ -14200,14 +14330,14 @@
       </p:sp>
       <p:sp>
         <p:nvSpPr>
-          <p:cNvPr id="115" name="FT1"/>
-          <p:cNvSpPr/>
-          <p:nvPr/>
-        </p:nvSpPr>
-        <p:spPr>
-          <a:xfrm>
-            <a:off x="6540500" y="2095500"/>
-            <a:ext cx="4953000" cy="1016000"/>
+          <p:cNvPr id="112" name="FT1"/>
+          <p:cNvSpPr/>
+          <p:nvPr/>
+        </p:nvSpPr>
+        <p:spPr>
+          <a:xfrm>
+            <a:off x="4597400" y="2032000"/>
+            <a:ext cx="3149600" cy="889000"/>
           </a:xfrm>
           <a:prstGeom prst="rect">
             <a:avLst/>
@@ -14223,11 +14353,11 @@
           <a:p>
             <a:pPr algn="l">
               <a:spcAft>
-                <a:spcPts val="300"/>
+                <a:spcPts val="200"/>
               </a:spcAft>
             </a:pPr>
             <a:r>
-              <a:rPr lang="en-GB" sz="1800" b="1" dirty="0">
+              <a:rPr lang="en-GB" sz="1600" b="1" dirty="0">
                 <a:solidFill>
                   <a:srgbClr val="1A2744"/>
                 </a:solidFill>
@@ -14239,31 +14369,31 @@
           <a:p>
             <a:pPr algn="l"/>
             <a:r>
-              <a:rPr lang="en-GB" sz="1400" dirty="0">
+              <a:rPr lang="en-GB" sz="1200" dirty="0">
                 <a:solidFill>
                   <a:srgbClr val="4A5568"/>
                 </a:solidFill>
                 <a:latin typeface="Source Sans Pro"/>
               </a:rPr>
-              <a:t>Statistical analysis run directly from your data with full transparency</a:t>
-            </a:r>
-          </a:p>
-        </p:txBody>
-      </p:sp>
-      <p:sp>
-        <p:nvSpPr>
-          <p:cNvPr id="116" name="F2"/>
-          <p:cNvSpPr/>
-          <p:nvPr/>
-        </p:nvSpPr>
-        <p:spPr>
-          <a:xfrm>
-            <a:off x="762000" y="3429000"/>
-            <a:ext cx="5334000" cy="1333500"/>
+              <a:t>Statistical analysis run directly from your data with full transparency.</a:t>
+            </a:r>
+          </a:p>
+        </p:txBody>
+      </p:sp>
+      <p:sp>
+        <p:nvSpPr>
+          <p:cNvPr id="113" name="F2"/>
+          <p:cNvSpPr/>
+          <p:nvPr/>
+        </p:nvSpPr>
+        <p:spPr>
+          <a:xfrm>
+            <a:off x="8128000" y="1879600"/>
+            <a:ext cx="3454400" cy="1143000"/>
           </a:xfrm>
           <a:prstGeom prst="roundRect">
             <a:avLst>
-              <a:gd name="adj" fmla="val 6000"/>
+              <a:gd name="adj" fmla="val 3000"/>
             </a:avLst>
           </a:prstGeom>
           <a:solidFill>
@@ -14285,43 +14415,43 @@
       </p:sp>
       <p:sp>
         <p:nvSpPr>
-          <p:cNvPr id="117" name="FA2"/>
-          <p:cNvSpPr/>
-          <p:nvPr/>
-        </p:nvSpPr>
-        <p:spPr>
-          <a:xfrm>
-            <a:off x="914400" y="3429000"/>
-            <a:ext cx="635000" cy="38100"/>
+          <p:cNvPr id="114" name="FA2"/>
+          <p:cNvSpPr/>
+          <p:nvPr/>
+        </p:nvSpPr>
+        <p:spPr>
+          <a:xfrm>
+            <a:off x="8280400" y="1879600"/>
+            <a:ext cx="508000" cy="38100"/>
           </a:xfrm>
           <a:prstGeom prst="rect">
             <a:avLst/>
           </a:prstGeom>
           <a:solidFill>
-            <a:srgbClr val="7C5CFC"/>
-          </a:solidFill>
-          <a:ln>
-            <a:noFill/>
-          </a:ln>
-        </p:spPr>
-        <p:txBody>
-          <a:bodyPr/>
-          <a:lstStyle/>
-          <a:p>
-            <a:endParaRPr lang="en-GB"/>
-          </a:p>
-        </p:txBody>
-      </p:sp>
-      <p:sp>
-        <p:nvSpPr>
-          <p:cNvPr id="118" name="FT2"/>
-          <p:cNvSpPr/>
-          <p:nvPr/>
-        </p:nvSpPr>
-        <p:spPr>
-          <a:xfrm>
-            <a:off x="952500" y="3619500"/>
-            <a:ext cx="4953000" cy="1016000"/>
+            <a:srgbClr val="E56B33"/>
+          </a:solidFill>
+          <a:ln>
+            <a:noFill/>
+          </a:ln>
+        </p:spPr>
+        <p:txBody>
+          <a:bodyPr/>
+          <a:lstStyle/>
+          <a:p>
+            <a:endParaRPr lang="en-GB"/>
+          </a:p>
+        </p:txBody>
+      </p:sp>
+      <p:sp>
+        <p:nvSpPr>
+          <p:cNvPr id="115" name="FT2"/>
+          <p:cNvSpPr/>
+          <p:nvPr/>
+        </p:nvSpPr>
+        <p:spPr>
+          <a:xfrm>
+            <a:off x="8280400" y="2032000"/>
+            <a:ext cx="3149600" cy="889000"/>
           </a:xfrm>
           <a:prstGeom prst="rect">
             <a:avLst/>
@@ -14337,11 +14467,11 @@
           <a:p>
             <a:pPr algn="l">
               <a:spcAft>
-                <a:spcPts val="300"/>
+                <a:spcPts val="200"/>
               </a:spcAft>
             </a:pPr>
             <a:r>
-              <a:rPr lang="en-GB" sz="1800" b="1" dirty="0">
+              <a:rPr lang="en-GB" sz="1600" b="1" dirty="0">
                 <a:solidFill>
                   <a:srgbClr val="1A2744"/>
                 </a:solidFill>
@@ -14353,31 +14483,31 @@
           <a:p>
             <a:pPr algn="l"/>
             <a:r>
-              <a:rPr lang="en-GB" sz="1400" dirty="0">
+              <a:rPr lang="en-GB" sz="1200" dirty="0">
                 <a:solidFill>
                   <a:srgbClr val="4A5568"/>
                 </a:solidFill>
                 <a:latin typeface="Source Sans Pro"/>
               </a:rPr>
-              <a:t>One dataset. One report. Useful for as long as the data is relevant</a:t>
-            </a:r>
-          </a:p>
-        </p:txBody>
-      </p:sp>
-      <p:sp>
-        <p:nvSpPr>
-          <p:cNvPr id="119" name="F3"/>
-          <p:cNvSpPr/>
-          <p:nvPr/>
-        </p:nvSpPr>
-        <p:spPr>
-          <a:xfrm>
-            <a:off x="6350000" y="3429000"/>
-            <a:ext cx="5334000" cy="1333500"/>
+              <a:t>One dataset. One report. Useful for as long as the data is relevant.</a:t>
+            </a:r>
+          </a:p>
+        </p:txBody>
+      </p:sp>
+      <p:sp>
+        <p:nvSpPr>
+          <p:cNvPr id="116" name="F3"/>
+          <p:cNvSpPr/>
+          <p:nvPr/>
+        </p:nvSpPr>
+        <p:spPr>
+          <a:xfrm>
+            <a:off x="762000" y="3149600"/>
+            <a:ext cx="5334000" cy="1143000"/>
           </a:xfrm>
           <a:prstGeom prst="roundRect">
             <a:avLst>
-              <a:gd name="adj" fmla="val 6000"/>
+              <a:gd name="adj" fmla="val 3000"/>
             </a:avLst>
           </a:prstGeom>
           <a:solidFill>
@@ -14399,43 +14529,43 @@
       </p:sp>
       <p:sp>
         <p:nvSpPr>
-          <p:cNvPr id="120" name="FA3"/>
-          <p:cNvSpPr/>
-          <p:nvPr/>
-        </p:nvSpPr>
-        <p:spPr>
-          <a:xfrm>
-            <a:off x="6502400" y="3429000"/>
-            <a:ext cx="635000" cy="38100"/>
+          <p:cNvPr id="117" name="FA3"/>
+          <p:cNvSpPr/>
+          <p:nvPr/>
+        </p:nvSpPr>
+        <p:spPr>
+          <a:xfrm>
+            <a:off x="914400" y="3149600"/>
+            <a:ext cx="508000" cy="38100"/>
           </a:xfrm>
           <a:prstGeom prst="rect">
             <a:avLst/>
           </a:prstGeom>
           <a:solidFill>
-            <a:srgbClr val="FFB020"/>
-          </a:solidFill>
-          <a:ln>
-            <a:noFill/>
-          </a:ln>
-        </p:spPr>
-        <p:txBody>
-          <a:bodyPr/>
-          <a:lstStyle/>
-          <a:p>
-            <a:endParaRPr lang="en-GB"/>
-          </a:p>
-        </p:txBody>
-      </p:sp>
-      <p:sp>
-        <p:nvSpPr>
-          <p:cNvPr id="121" name="FT3"/>
-          <p:cNvSpPr/>
-          <p:nvPr/>
-        </p:nvSpPr>
-        <p:spPr>
-          <a:xfrm>
-            <a:off x="6540500" y="3619500"/>
-            <a:ext cx="4953000" cy="1016000"/>
+            <a:srgbClr val="323367"/>
+          </a:solidFill>
+          <a:ln>
+            <a:noFill/>
+          </a:ln>
+        </p:spPr>
+        <p:txBody>
+          <a:bodyPr/>
+          <a:lstStyle/>
+          <a:p>
+            <a:endParaRPr lang="en-GB"/>
+          </a:p>
+        </p:txBody>
+      </p:sp>
+      <p:sp>
+        <p:nvSpPr>
+          <p:cNvPr id="118" name="FT3"/>
+          <p:cNvSpPr/>
+          <p:nvPr/>
+        </p:nvSpPr>
+        <p:spPr>
+          <a:xfrm>
+            <a:off x="914400" y="3302000"/>
+            <a:ext cx="5029200" cy="889000"/>
           </a:xfrm>
           <a:prstGeom prst="rect">
             <a:avLst/>
@@ -14451,11 +14581,11 @@
           <a:p>
             <a:pPr algn="l">
               <a:spcAft>
-                <a:spcPts val="300"/>
+                <a:spcPts val="200"/>
               </a:spcAft>
             </a:pPr>
             <a:r>
-              <a:rPr lang="en-GB" sz="1800" b="1" dirty="0">
+              <a:rPr lang="en-GB" sz="1600" b="1" dirty="0">
                 <a:solidFill>
                   <a:srgbClr val="1A2744"/>
                 </a:solidFill>
@@ -14467,58 +14597,148 @@
           <a:p>
             <a:pPr algn="l"/>
             <a:r>
-              <a:rPr lang="en-GB" sz="1400" dirty="0">
+              <a:rPr lang="en-GB" sz="1200" dirty="0">
                 <a:solidFill>
                   <a:srgbClr val="4A5568"/>
                 </a:solidFill>
                 <a:latin typeface="Source Sans Pro"/>
               </a:rPr>
-              <a:t>No subscription fees. No licence costs. No new Software. </a:t>
-            </a:r>
-          </a:p>
-          <a:p>
-            <a:pPr algn="l"/>
-            <a:r>
-              <a:rPr lang="en-GB" sz="1400" dirty="0">
-                <a:solidFill>
-                  <a:srgbClr val="4A5568"/>
-                </a:solidFill>
-                <a:latin typeface="Source Sans Pro"/>
-              </a:rPr>
-              <a:t>No installations. </a:t>
-            </a:r>
-          </a:p>
-          <a:p>
-            <a:pPr algn="l"/>
-            <a:r>
-              <a:rPr lang="en-GB" sz="1400" dirty="0">
-                <a:solidFill>
-                  <a:srgbClr val="4A5568"/>
-                </a:solidFill>
-                <a:latin typeface="Source Sans Pro"/>
-              </a:rPr>
-              <a:t>You pay per project.</a:t>
-            </a:r>
-          </a:p>
-        </p:txBody>
-      </p:sp>
-      <p:sp>
-        <p:nvSpPr>
-          <p:cNvPr id="140" name="Quote"/>
-          <p:cNvSpPr/>
-          <p:nvPr/>
-        </p:nvSpPr>
-        <p:spPr>
-          <a:xfrm>
-            <a:off x="762000" y="5207000"/>
-            <a:ext cx="10668000" cy="889000"/>
+              <a:t>No subscriptions. No licence costs. No installations. You pay per project.</a:t>
+            </a:r>
+          </a:p>
+        </p:txBody>
+      </p:sp>
+      <p:sp>
+        <p:nvSpPr>
+          <p:cNvPr id="119" name="F4"/>
+          <p:cNvSpPr/>
+          <p:nvPr/>
+        </p:nvSpPr>
+        <p:spPr>
+          <a:xfrm>
+            <a:off x="6350000" y="3149600"/>
+            <a:ext cx="5334000" cy="1143000"/>
           </a:xfrm>
           <a:prstGeom prst="roundRect">
             <a:avLst>
-              <a:gd name="adj" fmla="val 12000"/>
+              <a:gd name="adj" fmla="val 3000"/>
             </a:avLst>
           </a:prstGeom>
           <a:solidFill>
+            <a:srgbClr val="F5F7FA"/>
+          </a:solidFill>
+          <a:ln w="6350">
+            <a:solidFill>
+              <a:srgbClr val="E2E8F0"/>
+            </a:solidFill>
+          </a:ln>
+        </p:spPr>
+        <p:txBody>
+          <a:bodyPr/>
+          <a:lstStyle/>
+          <a:p>
+            <a:endParaRPr lang="en-GB"/>
+          </a:p>
+        </p:txBody>
+      </p:sp>
+      <p:sp>
+        <p:nvSpPr>
+          <p:cNvPr id="120" name="FA4"/>
+          <p:cNvSpPr/>
+          <p:nvPr/>
+        </p:nvSpPr>
+        <p:spPr>
+          <a:xfrm>
+            <a:off x="6502400" y="3149600"/>
+            <a:ext cx="508000" cy="38100"/>
+          </a:xfrm>
+          <a:prstGeom prst="rect">
+            <a:avLst/>
+          </a:prstGeom>
+          <a:solidFill>
+            <a:srgbClr val="CC9900"/>
+          </a:solidFill>
+          <a:ln>
+            <a:noFill/>
+          </a:ln>
+        </p:spPr>
+        <p:txBody>
+          <a:bodyPr/>
+          <a:lstStyle/>
+          <a:p>
+            <a:endParaRPr lang="en-GB"/>
+          </a:p>
+        </p:txBody>
+      </p:sp>
+      <p:sp>
+        <p:nvSpPr>
+          <p:cNvPr id="121" name="FT4"/>
+          <p:cNvSpPr/>
+          <p:nvPr/>
+        </p:nvSpPr>
+        <p:spPr>
+          <a:xfrm>
+            <a:off x="6502400" y="3302000"/>
+            <a:ext cx="5029200" cy="889000"/>
+          </a:xfrm>
+          <a:prstGeom prst="rect">
+            <a:avLst/>
+          </a:prstGeom>
+          <a:noFill/>
+          <a:ln>
+            <a:noFill/>
+          </a:ln>
+        </p:spPr>
+        <p:txBody>
+          <a:bodyPr wrap="square" lIns="0" tIns="0" rIns="0" bIns="0" anchor="t"/>
+          <a:lstStyle/>
+          <a:p>
+            <a:pPr algn="l">
+              <a:spcAft>
+                <a:spcPts val="200"/>
+              </a:spcAft>
+            </a:pPr>
+            <a:r>
+              <a:rPr lang="en-GB" sz="1600" b="1" dirty="0">
+                <a:solidFill>
+                  <a:srgbClr val="1A2744"/>
+                </a:solidFill>
+                <a:latin typeface="Raleway"/>
+              </a:rPr>
+              <a:t>Bring Your Own Data</a:t>
+            </a:r>
+          </a:p>
+          <a:p>
+            <a:pPr algn="l"/>
+            <a:r>
+              <a:rPr lang="en-GB" sz="1200" dirty="0">
+                <a:solidFill>
+                  <a:srgbClr val="4A5568"/>
+                </a:solidFill>
+                <a:latin typeface="Source Sans Pro"/>
+              </a:rPr>
+              <a:t>Works with any survey dataset, whether fieldwork was commissioned through us or not. Have data sitting unused? We can breathe life into it.</a:t>
+            </a:r>
+          </a:p>
+        </p:txBody>
+      </p:sp>
+      <p:sp>
+        <p:nvSpPr>
+          <p:cNvPr id="122" name="Quote"/>
+          <p:cNvSpPr/>
+          <p:nvPr/>
+        </p:nvSpPr>
+        <p:spPr>
+          <a:xfrm>
+            <a:off x="762000" y="4508500"/>
+            <a:ext cx="10668000" cy="698500"/>
+          </a:xfrm>
+          <a:prstGeom prst="roundRect">
+            <a:avLst>
+              <a:gd name="adj" fmla="val 8000"/>
+            </a:avLst>
+          </a:prstGeom>
+          <a:solidFill>
             <a:srgbClr val="323367"/>
           </a:solidFill>
           <a:ln>
@@ -14526,55 +14746,26 @@
           </a:ln>
         </p:spPr>
         <p:txBody>
-          <a:bodyPr wrap="square" lIns="182880" tIns="45720" rIns="182880" bIns="45720" anchor="ctr"/>
+          <a:bodyPr wrap="square" lIns="72000" tIns="36000" rIns="72000" bIns="36000" anchor="ctr"/>
           <a:lstStyle/>
           <a:p>
             <a:pPr algn="ctr"/>
             <a:r>
-              <a:rPr lang="en-GB" sz="1600" i="1" dirty="0">
+              <a:rPr lang="en-GB" sz="1400" i="1" dirty="0">
                 <a:solidFill>
                   <a:srgbClr val="CC9900"/>
                 </a:solidFill>
                 <a:latin typeface="Source Sans Pro"/>
               </a:rPr>
-              <a:t>One dataset. One report. Useful for as long as the data is relevant.</a:t>
-            </a:r>
-          </a:p>
-        </p:txBody>
-      </p:sp>
-      <p:sp>
-        <p:nvSpPr>
-          <p:cNvPr id="150" name="BA"/>
-          <p:cNvSpPr/>
-          <p:nvPr/>
-        </p:nvSpPr>
-        <p:spPr>
-          <a:xfrm>
-            <a:off x="0" y="6807200"/>
-            <a:ext cx="12192000" cy="50800"/>
-          </a:xfrm>
-          <a:prstGeom prst="rect">
-            <a:avLst/>
-          </a:prstGeom>
-          <a:solidFill>
-            <a:srgbClr val="CC9900"/>
-          </a:solidFill>
-          <a:ln>
-            <a:noFill/>
-          </a:ln>
-        </p:spPr>
-        <p:txBody>
-          <a:bodyPr/>
-          <a:lstStyle/>
-          <a:p>
-            <a:endParaRPr lang="en-GB"/>
+              <a:t>Five reasons to choose Turas — interactive, rigorous, permanent, affordable, and open to any dataset.</a:t>
+            </a:r>
           </a:p>
         </p:txBody>
       </p:sp>
     </p:spTree>
     <p:extLst>
       <p:ext uri="{BB962C8B-B14F-4D97-AF65-F5344CB8AC3E}">
-        <p14:creationId xmlns:p14="http://schemas.microsoft.com/office/powerpoint/2010/main" val="82650872"/>
+        <p14:creationId xmlns:p14="http://schemas.microsoft.com/office/powerpoint/2010/main" val="427254992"/>
       </p:ext>
     </p:extLst>
   </p:cSld>
@@ -15658,7 +15849,25 @@
                 </a:solidFill>
                 <a:latin typeface="Source Sans Pro"/>
               </a:rPr>
-              <a:t>The Research LampPost is a member of the Southern African Marketing Research Association. Duncan Brett is SAMRA-accredited with 30+ years in quantitative market research.</a:t>
+              <a:t>The Research </a:t>
+            </a:r>
+            <a:r>
+              <a:rPr lang="en-GB" sz="1400" dirty="0" err="1">
+                <a:solidFill>
+                  <a:srgbClr val="4A5568"/>
+                </a:solidFill>
+                <a:latin typeface="Source Sans Pro"/>
+              </a:rPr>
+              <a:t>LampPost</a:t>
+            </a:r>
+            <a:r>
+              <a:rPr lang="en-GB" sz="1400" dirty="0">
+                <a:solidFill>
+                  <a:srgbClr val="4A5568"/>
+                </a:solidFill>
+                <a:latin typeface="Source Sans Pro"/>
+              </a:rPr>
+              <a:t> are organisational members of the Southern African Marketing Research Association. Duncan Brett developed Turas and is a SAMRA-Accredited Researcher with 30+ years in quantitative market research.</a:t>
             </a:r>
           </a:p>
         </p:txBody>
@@ -16140,8 +16349,8 @@
         </p:nvSpPr>
         <p:spPr>
           <a:xfrm>
-            <a:off x="762000" y="1968500"/>
-            <a:ext cx="3479800" cy="2667000"/>
+            <a:off x="990600" y="1968500"/>
+            <a:ext cx="5080000" cy="2667000"/>
           </a:xfrm>
           <a:prstGeom prst="roundRect">
             <a:avLst>
@@ -16173,8 +16382,8 @@
         </p:nvSpPr>
         <p:spPr>
           <a:xfrm>
-            <a:off x="952500" y="2032000"/>
-            <a:ext cx="3098800" cy="2476500"/>
+            <a:off x="1181100" y="2032000"/>
+            <a:ext cx="4699000" cy="2476500"/>
           </a:xfrm>
           <a:prstGeom prst="rect">
             <a:avLst/>
@@ -16216,92 +16425,7 @@
                 </a:solidFill>
                 <a:latin typeface="Raleway"/>
               </a:rPr>
-              <a:t>No Cloud Upload</a:t>
-            </a:r>
-          </a:p>
-          <a:p>
-            <a:pPr algn="ctr"/>
-            <a:r>
-              <a:rPr lang="en-GB" sz="1400" dirty="0">
-                <a:solidFill>
-                  <a:srgbClr val="4A5568"/>
-                </a:solidFill>
-                <a:latin typeface="Source Sans Pro"/>
-              </a:rPr>
-              <a:t>Your dataset is never uploaded to a cloud platform or shared with a third party</a:t>
-            </a:r>
-          </a:p>
-        </p:txBody>
-      </p:sp>
-      <p:sp>
-        <p:nvSpPr>
-          <p:cNvPr id="112" name="S1"/>
-          <p:cNvSpPr/>
-          <p:nvPr/>
-        </p:nvSpPr>
-        <p:spPr>
-          <a:xfrm>
-            <a:off x="4495800" y="1968500"/>
-            <a:ext cx="3479800" cy="2667000"/>
-          </a:xfrm>
-          <a:prstGeom prst="roundRect">
-            <a:avLst>
-              <a:gd name="adj" fmla="val 6000"/>
-            </a:avLst>
-          </a:prstGeom>
-          <a:solidFill>
-            <a:srgbClr val="F5F7FA"/>
-          </a:solidFill>
-          <a:ln w="6350">
-            <a:solidFill>
-              <a:srgbClr val="E2E8F0"/>
-            </a:solidFill>
-          </a:ln>
-        </p:spPr>
-        <p:txBody>
-          <a:bodyPr/>
-          <a:lstStyle/>
-          <a:p>
-            <a:endParaRPr lang="en-GB"/>
-          </a:p>
-        </p:txBody>
-      </p:sp>
-      <p:sp>
-        <p:nvSpPr>
-          <p:cNvPr id="113" name="ST1"/>
-          <p:cNvSpPr/>
-          <p:nvPr/>
-        </p:nvSpPr>
-        <p:spPr>
-          <a:xfrm>
-            <a:off x="4686300" y="2032000"/>
-            <a:ext cx="3098800" cy="2476500"/>
-          </a:xfrm>
-          <a:prstGeom prst="rect">
-            <a:avLst/>
-          </a:prstGeom>
-          <a:noFill/>
-          <a:ln>
-            <a:noFill/>
-          </a:ln>
-        </p:spPr>
-        <p:txBody>
-          <a:bodyPr wrap="square" lIns="0" tIns="45720" rIns="0" bIns="0" anchor="t"/>
-          <a:lstStyle/>
-          <a:p>
-            <a:pPr algn="ctr">
-              <a:spcAft>
-                <a:spcPts val="200"/>
-              </a:spcAft>
-            </a:pPr>
-            <a:r>
-              <a:rPr lang="en-GB" sz="1400" dirty="0">
-                <a:solidFill>
-                  <a:srgbClr val="CC9900"/>
-                </a:solidFill>
-                <a:latin typeface="Raleway"/>
-              </a:rPr>
-              <a:t>━━━</a:t>
+              <a:t>Data Security</a:t>
             </a:r>
           </a:p>
           <a:p>
@@ -16311,25 +16435,13 @@
               </a:spcAft>
             </a:pPr>
             <a:r>
-              <a:rPr lang="en-GB" sz="1800" b="1" dirty="0">
-                <a:solidFill>
-                  <a:srgbClr val="1A2744"/>
-                </a:solidFill>
-                <a:latin typeface="Raleway"/>
-              </a:rPr>
-              <a:t>Controlled Environment</a:t>
-            </a:r>
-          </a:p>
-          <a:p>
-            <a:pPr algn="ctr"/>
-            <a:r>
               <a:rPr lang="en-GB" sz="1400" dirty="0">
                 <a:solidFill>
                   <a:srgbClr val="4A5568"/>
                 </a:solidFill>
                 <a:latin typeface="Source Sans Pro"/>
               </a:rPr>
-              <a:t>All analysis runs on our own hardware in a secure, controlled environment</a:t>
+              <a:t>Your data is analysed entirely on our own hardware — never processed by a third-party analytical platform or shared with an external service</a:t>
             </a:r>
           </a:p>
         </p:txBody>
@@ -16342,8 +16454,8 @@
         </p:nvSpPr>
         <p:spPr>
           <a:xfrm>
-            <a:off x="8229600" y="1968500"/>
-            <a:ext cx="3479800" cy="2667000"/>
+            <a:off x="6324600" y="1968500"/>
+            <a:ext cx="5080000" cy="2667000"/>
           </a:xfrm>
           <a:prstGeom prst="roundRect">
             <a:avLst>
@@ -16375,8 +16487,8 @@
         </p:nvSpPr>
         <p:spPr>
           <a:xfrm>
-            <a:off x="8420100" y="2032000"/>
-            <a:ext cx="3098800" cy="2476500"/>
+            <a:off x="6515100" y="2032000"/>
+            <a:ext cx="4699000" cy="2476500"/>
           </a:xfrm>
           <a:prstGeom prst="rect">
             <a:avLst/>
@@ -16764,6 +16876,35 @@
       </p:sp>
       <p:sp>
         <p:nvSpPr>
+          <p:cNvPr id="150" name="BA"/>
+          <p:cNvSpPr/>
+          <p:nvPr/>
+        </p:nvSpPr>
+        <p:spPr>
+          <a:xfrm>
+            <a:off x="0" y="6807200"/>
+            <a:ext cx="12192000" cy="50800"/>
+          </a:xfrm>
+          <a:prstGeom prst="rect">
+            <a:avLst/>
+          </a:prstGeom>
+          <a:solidFill>
+            <a:srgbClr val="CC9900"/>
+          </a:solidFill>
+          <a:ln>
+            <a:noFill/>
+          </a:ln>
+        </p:spPr>
+        <p:txBody>
+          <a:bodyPr/>
+          <a:lstStyle/>
+          <a:p>
+            <a:endParaRPr lang="en-GB"/>
+          </a:p>
+        </p:txBody>
+      </p:sp>
+      <p:sp>
+        <p:nvSpPr>
           <p:cNvPr id="106" name="MA"/>
           <p:cNvSpPr/>
           <p:nvPr/>
@@ -16793,14 +16934,396 @@
       </p:sp>
       <p:sp>
         <p:nvSpPr>
-          <p:cNvPr id="110" name="Fast"/>
-          <p:cNvSpPr/>
-          <p:nvPr/>
-        </p:nvSpPr>
-        <p:spPr>
-          <a:xfrm>
-            <a:off x="762000" y="1905000"/>
-            <a:ext cx="5334000" cy="1524000"/>
+          <p:cNvPr id="107" name="Fast"/>
+          <p:cNvSpPr/>
+          <p:nvPr/>
+        </p:nvSpPr>
+        <p:spPr>
+          <a:xfrm>
+            <a:off x="762000" y="1879600"/>
+            <a:ext cx="5207000" cy="1651000"/>
+          </a:xfrm>
+          <a:prstGeom prst="roundRect">
+            <a:avLst>
+              <a:gd name="adj" fmla="val 5000"/>
+            </a:avLst>
+          </a:prstGeom>
+          <a:solidFill>
+            <a:srgbClr val="F5F7FA"/>
+          </a:solidFill>
+          <a:ln w="12700">
+            <a:solidFill>
+              <a:srgbClr val="CC9900"/>
+            </a:solidFill>
+            <a:prstDash val="dash"/>
+          </a:ln>
+        </p:spPr>
+        <p:txBody>
+          <a:bodyPr wrap="square" lIns="72000" tIns="54000" rIns="72000" bIns="36000" anchor="t"/>
+          <a:lstStyle/>
+          <a:p>
+            <a:pPr algn="ctr">
+              <a:spcAft>
+                <a:spcPts val="100"/>
+              </a:spcAft>
+            </a:pPr>
+            <a:r>
+              <a:rPr lang="en-GB" sz="3600" b="1" dirty="0">
+                <a:solidFill>
+                  <a:srgbClr val="CC9900"/>
+                </a:solidFill>
+                <a:latin typeface="Raleway"/>
+              </a:rPr>
+              <a:t>1 Day*</a:t>
+            </a:r>
+          </a:p>
+          <a:p>
+            <a:pPr algn="ctr"/>
+            <a:r>
+              <a:rPr lang="en-GB" sz="1400" dirty="0">
+                <a:solidFill>
+                  <a:srgbClr val="4A5568"/>
+                </a:solidFill>
+                <a:latin typeface="Source Sans Pro"/>
+              </a:rPr>
+              <a:t>Preliminary output once data is clean and formatted</a:t>
+            </a:r>
+          </a:p>
+        </p:txBody>
+      </p:sp>
+      <p:sp>
+        <p:nvSpPr>
+          <p:cNvPr id="108" name="Slow"/>
+          <p:cNvSpPr/>
+          <p:nvPr/>
+        </p:nvSpPr>
+        <p:spPr>
+          <a:xfrm>
+            <a:off x="6223000" y="1879600"/>
+            <a:ext cx="5207000" cy="1651000"/>
+          </a:xfrm>
+          <a:prstGeom prst="roundRect">
+            <a:avLst>
+              <a:gd name="adj" fmla="val 5000"/>
+            </a:avLst>
+          </a:prstGeom>
+          <a:solidFill>
+            <a:srgbClr val="F5F7FA"/>
+          </a:solidFill>
+          <a:ln w="12700">
+            <a:solidFill>
+              <a:srgbClr val="E53E3E"/>
+            </a:solidFill>
+            <a:prstDash val="dash"/>
+          </a:ln>
+        </p:spPr>
+        <p:txBody>
+          <a:bodyPr wrap="square" lIns="72000" tIns="54000" rIns="72000" bIns="36000" anchor="t"/>
+          <a:lstStyle/>
+          <a:p>
+            <a:pPr algn="ctr">
+              <a:spcAft>
+                <a:spcPts val="100"/>
+              </a:spcAft>
+            </a:pPr>
+            <a:r>
+              <a:rPr lang="en-GB" sz="3600" b="1" dirty="0">
+                <a:solidFill>
+                  <a:srgbClr val="E53E3E"/>
+                </a:solidFill>
+                <a:latin typeface="Raleway"/>
+              </a:rPr>
+              <a:t>Weeks</a:t>
+            </a:r>
+          </a:p>
+          <a:p>
+            <a:pPr algn="ctr"/>
+            <a:r>
+              <a:rPr lang="en-GB" sz="1400" dirty="0">
+                <a:solidFill>
+                  <a:srgbClr val="4A5568"/>
+                </a:solidFill>
+                <a:latin typeface="Source Sans Pro"/>
+              </a:rPr>
+              <a:t>Traditional analysis timeline</a:t>
+            </a:r>
+          </a:p>
+        </p:txBody>
+      </p:sp>
+      <p:sp>
+        <p:nvSpPr>
+          <p:cNvPr id="109" name="Caveat"/>
+          <p:cNvSpPr/>
+          <p:nvPr/>
+        </p:nvSpPr>
+        <p:spPr>
+          <a:xfrm>
+            <a:off x="762000" y="3581400"/>
+            <a:ext cx="10668000" cy="279400"/>
+          </a:xfrm>
+          <a:prstGeom prst="rect">
+            <a:avLst/>
+          </a:prstGeom>
+          <a:noFill/>
+          <a:ln>
+            <a:noFill/>
+          </a:ln>
+        </p:spPr>
+        <p:txBody>
+          <a:bodyPr wrap="square" lIns="0" tIns="0" rIns="0" bIns="0" anchor="t"/>
+          <a:lstStyle/>
+          <a:p>
+            <a:pPr algn="l"/>
+            <a:r>
+              <a:rPr lang="en-GB" sz="1000" i="1" dirty="0">
+                <a:solidFill>
+                  <a:srgbClr val="94A3B8"/>
+                </a:solidFill>
+                <a:latin typeface="Source Sans Pro"/>
+              </a:rPr>
+              <a:t>*Post data cleaning. Actual turnaround depends on data layout and processing complexity.</a:t>
+            </a:r>
+          </a:p>
+        </p:txBody>
+      </p:sp>
+      <p:sp>
+        <p:nvSpPr>
+          <p:cNvPr id="110" name="ConsBG"/>
+          <p:cNvSpPr/>
+          <p:nvPr/>
+        </p:nvSpPr>
+        <p:spPr>
+          <a:xfrm>
+            <a:off x="762000" y="3962400"/>
+            <a:ext cx="5207000" cy="1270000"/>
+          </a:xfrm>
+          <a:prstGeom prst="roundRect">
+            <a:avLst>
+              <a:gd name="adj" fmla="val 3000"/>
+            </a:avLst>
+          </a:prstGeom>
+          <a:solidFill>
+            <a:srgbClr val="F5F7FA"/>
+          </a:solidFill>
+          <a:ln w="6350">
+            <a:solidFill>
+              <a:srgbClr val="E2E8F0"/>
+            </a:solidFill>
+          </a:ln>
+        </p:spPr>
+        <p:txBody>
+          <a:bodyPr/>
+          <a:lstStyle/>
+          <a:p>
+            <a:endParaRPr lang="en-GB"/>
+          </a:p>
+        </p:txBody>
+      </p:sp>
+      <p:sp>
+        <p:nvSpPr>
+          <p:cNvPr id="111" name="ConsAcc"/>
+          <p:cNvSpPr/>
+          <p:nvPr/>
+        </p:nvSpPr>
+        <p:spPr>
+          <a:xfrm>
+            <a:off x="762000" y="3962400"/>
+            <a:ext cx="63500" cy="1270000"/>
+          </a:xfrm>
+          <a:prstGeom prst="rect">
+            <a:avLst/>
+          </a:prstGeom>
+          <a:solidFill>
+            <a:srgbClr val="4A90D9"/>
+          </a:solidFill>
+          <a:ln>
+            <a:noFill/>
+          </a:ln>
+        </p:spPr>
+        <p:txBody>
+          <a:bodyPr/>
+          <a:lstStyle/>
+          <a:p>
+            <a:endParaRPr lang="en-GB"/>
+          </a:p>
+        </p:txBody>
+      </p:sp>
+      <p:sp>
+        <p:nvSpPr>
+          <p:cNvPr id="112" name="ConsTxt"/>
+          <p:cNvSpPr/>
+          <p:nvPr/>
+        </p:nvSpPr>
+        <p:spPr>
+          <a:xfrm>
+            <a:off x="1016000" y="4064000"/>
+            <a:ext cx="4762500" cy="1066800"/>
+          </a:xfrm>
+          <a:prstGeom prst="rect">
+            <a:avLst/>
+          </a:prstGeom>
+          <a:noFill/>
+          <a:ln>
+            <a:noFill/>
+          </a:ln>
+        </p:spPr>
+        <p:txBody>
+          <a:bodyPr wrap="square" lIns="0" tIns="0" rIns="0" bIns="0" anchor="t"/>
+          <a:lstStyle/>
+          <a:p>
+            <a:pPr algn="l">
+              <a:spcAft>
+                <a:spcPts val="200"/>
+              </a:spcAft>
+            </a:pPr>
+            <a:r>
+              <a:rPr lang="en-GB" sz="1600" b="1" dirty="0">
+                <a:solidFill>
+                  <a:srgbClr val="1A2744"/>
+                </a:solidFill>
+                <a:latin typeface="Raleway"/>
+              </a:rPr>
+              <a:t>Built-in Consistency</a:t>
+            </a:r>
+          </a:p>
+          <a:p>
+            <a:pPr algn="l"/>
+            <a:r>
+              <a:rPr lang="en-GB" sz="1200" dirty="0">
+                <a:solidFill>
+                  <a:srgbClr val="4A5568"/>
+                </a:solidFill>
+                <a:latin typeface="Source Sans Pro"/>
+              </a:rPr>
+              <a:t>Same methods, every time. For tracking studies, results stay comparable across waves.</a:t>
+            </a:r>
+          </a:p>
+        </p:txBody>
+      </p:sp>
+      <p:sp>
+        <p:nvSpPr>
+          <p:cNvPr id="113" name="OldBG"/>
+          <p:cNvSpPr/>
+          <p:nvPr/>
+        </p:nvSpPr>
+        <p:spPr>
+          <a:xfrm>
+            <a:off x="6223000" y="3962400"/>
+            <a:ext cx="5207000" cy="1270000"/>
+          </a:xfrm>
+          <a:prstGeom prst="roundRect">
+            <a:avLst>
+              <a:gd name="adj" fmla="val 3000"/>
+            </a:avLst>
+          </a:prstGeom>
+          <a:solidFill>
+            <a:srgbClr val="F5F7FA"/>
+          </a:solidFill>
+          <a:ln w="6350">
+            <a:solidFill>
+              <a:srgbClr val="E2E8F0"/>
+            </a:solidFill>
+          </a:ln>
+        </p:spPr>
+        <p:txBody>
+          <a:bodyPr/>
+          <a:lstStyle/>
+          <a:p>
+            <a:endParaRPr lang="en-GB"/>
+          </a:p>
+        </p:txBody>
+      </p:sp>
+      <p:sp>
+        <p:nvSpPr>
+          <p:cNvPr id="114" name="OldAcc"/>
+          <p:cNvSpPr/>
+          <p:nvPr/>
+        </p:nvSpPr>
+        <p:spPr>
+          <a:xfrm>
+            <a:off x="6223000" y="3962400"/>
+            <a:ext cx="63500" cy="1270000"/>
+          </a:xfrm>
+          <a:prstGeom prst="rect">
+            <a:avLst/>
+          </a:prstGeom>
+          <a:solidFill>
+            <a:srgbClr val="E56B33"/>
+          </a:solidFill>
+          <a:ln>
+            <a:noFill/>
+          </a:ln>
+        </p:spPr>
+        <p:txBody>
+          <a:bodyPr/>
+          <a:lstStyle/>
+          <a:p>
+            <a:endParaRPr lang="en-GB"/>
+          </a:p>
+        </p:txBody>
+      </p:sp>
+      <p:sp>
+        <p:nvSpPr>
+          <p:cNvPr id="115" name="OldTxt"/>
+          <p:cNvSpPr/>
+          <p:nvPr/>
+        </p:nvSpPr>
+        <p:spPr>
+          <a:xfrm>
+            <a:off x="6477000" y="4064000"/>
+            <a:ext cx="4762500" cy="1066800"/>
+          </a:xfrm>
+          <a:prstGeom prst="rect">
+            <a:avLst/>
+          </a:prstGeom>
+          <a:noFill/>
+          <a:ln>
+            <a:noFill/>
+          </a:ln>
+        </p:spPr>
+        <p:txBody>
+          <a:bodyPr wrap="square" lIns="0" tIns="0" rIns="0" bIns="0" anchor="t"/>
+          <a:lstStyle/>
+          <a:p>
+            <a:pPr algn="l">
+              <a:spcAft>
+                <a:spcPts val="200"/>
+              </a:spcAft>
+            </a:pPr>
+            <a:r>
+              <a:rPr lang="en-GB" sz="1600" b="1" dirty="0">
+                <a:solidFill>
+                  <a:srgbClr val="1A2744"/>
+                </a:solidFill>
+                <a:latin typeface="Raleway"/>
+              </a:rPr>
+              <a:t>Revive Old Surveys</a:t>
+            </a:r>
+          </a:p>
+          <a:p>
+            <a:pPr algn="l"/>
+            <a:r>
+              <a:rPr lang="en-GB" sz="1200" dirty="0">
+                <a:solidFill>
+                  <a:srgbClr val="4A5568"/>
+                </a:solidFill>
+                <a:latin typeface="Source Sans Pro"/>
+              </a:rPr>
+              <a:t>Got old survey data gathering dust? We can re-run it through Turas and unlock insights you never extracted.</a:t>
+            </a:r>
+          </a:p>
+        </p:txBody>
+      </p:sp>
+      <p:sp>
+        <p:nvSpPr>
+          <p:cNvPr id="116" name="Call"/>
+          <p:cNvSpPr/>
+          <p:nvPr/>
+        </p:nvSpPr>
+        <p:spPr>
+          <a:xfrm>
+            <a:off x="762000" y="5461000"/>
+            <a:ext cx="10668000" cy="698500"/>
           </a:xfrm>
           <a:prstGeom prst="roundRect">
             <a:avLst>
@@ -16808,294 +17331,33 @@
             </a:avLst>
           </a:prstGeom>
           <a:solidFill>
-            <a:srgbClr val="F0FFF4"/>
-          </a:solidFill>
-          <a:ln w="12700">
-            <a:solidFill>
-              <a:srgbClr val="CC9900"/>
-            </a:solidFill>
-          </a:ln>
-        </p:spPr>
-        <p:txBody>
-          <a:bodyPr wrap="square" lIns="137160" tIns="45720" rIns="137160" bIns="45720" anchor="ctr"/>
-          <a:lstStyle/>
-          <a:p>
-            <a:pPr algn="ctr">
-              <a:spcAft>
-                <a:spcPts val="200"/>
-              </a:spcAft>
-            </a:pPr>
-            <a:r>
-              <a:rPr lang="en-GB" sz="4000" b="1" dirty="0">
+            <a:srgbClr val="323367"/>
+          </a:solidFill>
+          <a:ln>
+            <a:noFill/>
+          </a:ln>
+        </p:spPr>
+        <p:txBody>
+          <a:bodyPr wrap="square" lIns="72000" tIns="36000" rIns="72000" bIns="36000" anchor="ctr"/>
+          <a:lstStyle/>
+          <a:p>
+            <a:pPr algn="ctr"/>
+            <a:r>
+              <a:rPr lang="en-GB" sz="1400" i="1" dirty="0">
                 <a:solidFill>
                   <a:srgbClr val="CC9900"/>
                 </a:solidFill>
-                <a:latin typeface="Raleway"/>
-              </a:rPr>
-              <a:t>1 Day</a:t>
-            </a:r>
-          </a:p>
-          <a:p>
-            <a:pPr algn="ctr"/>
-            <a:r>
-              <a:rPr lang="en-GB" sz="1400" dirty="0">
-                <a:solidFill>
-                  <a:srgbClr val="4A5568"/>
-                </a:solidFill>
                 <a:latin typeface="Source Sans Pro"/>
               </a:rPr>
-              <a:t>Preliminary output after fieldwork closes</a:t>
-            </a:r>
-          </a:p>
-        </p:txBody>
-      </p:sp>
-      <p:sp>
-        <p:nvSpPr>
-          <p:cNvPr id="111" name="Slow"/>
-          <p:cNvSpPr/>
-          <p:nvPr/>
-        </p:nvSpPr>
-        <p:spPr>
-          <a:xfrm>
-            <a:off x="6350000" y="1905000"/>
-            <a:ext cx="5080000" cy="1524000"/>
-          </a:xfrm>
-          <a:prstGeom prst="roundRect">
-            <a:avLst>
-              <a:gd name="adj" fmla="val 8000"/>
-            </a:avLst>
-          </a:prstGeom>
-          <a:solidFill>
-            <a:srgbClr val="FFF5F5"/>
-          </a:solidFill>
-          <a:ln w="12700">
-            <a:solidFill>
-              <a:srgbClr val="E53E3E"/>
-            </a:solidFill>
-          </a:ln>
-        </p:spPr>
-        <p:txBody>
-          <a:bodyPr wrap="square" lIns="137160" tIns="45720" rIns="137160" bIns="45720" anchor="ctr"/>
-          <a:lstStyle/>
-          <a:p>
-            <a:pPr algn="ctr">
-              <a:spcAft>
-                <a:spcPts val="200"/>
-              </a:spcAft>
-            </a:pPr>
-            <a:r>
-              <a:rPr lang="en-GB" sz="4000" b="1" dirty="0">
-                <a:solidFill>
-                  <a:srgbClr val="E53E3E"/>
-                </a:solidFill>
-                <a:latin typeface="Raleway"/>
-              </a:rPr>
-              <a:t>Weeks</a:t>
-            </a:r>
-          </a:p>
-          <a:p>
-            <a:pPr algn="ctr"/>
-            <a:r>
-              <a:rPr lang="en-GB" sz="1400" dirty="0">
-                <a:solidFill>
-                  <a:srgbClr val="4A5568"/>
-                </a:solidFill>
-                <a:latin typeface="Source Sans Pro"/>
-              </a:rPr>
-              <a:t>Traditional analysis timeline</a:t>
-            </a:r>
-          </a:p>
-        </p:txBody>
-      </p:sp>
-      <p:sp>
-        <p:nvSpPr>
-          <p:cNvPr id="120" name="Cons"/>
-          <p:cNvSpPr/>
-          <p:nvPr/>
-        </p:nvSpPr>
-        <p:spPr>
-          <a:xfrm>
-            <a:off x="762000" y="3746500"/>
-            <a:ext cx="10668000" cy="1270000"/>
-          </a:xfrm>
-          <a:prstGeom prst="roundRect">
-            <a:avLst>
-              <a:gd name="adj" fmla="val 6000"/>
-            </a:avLst>
-          </a:prstGeom>
-          <a:solidFill>
-            <a:srgbClr val="F5F7FA"/>
-          </a:solidFill>
-          <a:ln w="6350">
-            <a:solidFill>
-              <a:srgbClr val="E2E8F0"/>
-            </a:solidFill>
-          </a:ln>
-        </p:spPr>
-        <p:txBody>
-          <a:bodyPr/>
-          <a:lstStyle/>
-          <a:p>
-            <a:endParaRPr lang="en-GB"/>
-          </a:p>
-        </p:txBody>
-      </p:sp>
-      <p:sp>
-        <p:nvSpPr>
-          <p:cNvPr id="121" name="CAcc"/>
-          <p:cNvSpPr/>
-          <p:nvPr/>
-        </p:nvSpPr>
-        <p:spPr>
-          <a:xfrm>
-            <a:off x="762000" y="3746500"/>
-            <a:ext cx="63500" cy="1270000"/>
-          </a:xfrm>
-          <a:prstGeom prst="roundRect">
-            <a:avLst>
-              <a:gd name="adj" fmla="val 50000"/>
-            </a:avLst>
-          </a:prstGeom>
-          <a:solidFill>
-            <a:srgbClr val="7C5CFC"/>
-          </a:solidFill>
-          <a:ln>
-            <a:noFill/>
-          </a:ln>
-        </p:spPr>
-        <p:txBody>
-          <a:bodyPr/>
-          <a:lstStyle/>
-          <a:p>
-            <a:endParaRPr lang="en-GB"/>
-          </a:p>
-        </p:txBody>
-      </p:sp>
-      <p:sp>
-        <p:nvSpPr>
-          <p:cNvPr id="122" name="CTxt"/>
-          <p:cNvSpPr/>
-          <p:nvPr/>
-        </p:nvSpPr>
-        <p:spPr>
-          <a:xfrm>
-            <a:off x="1041400" y="3873500"/>
-            <a:ext cx="10160000" cy="1016000"/>
-          </a:xfrm>
-          <a:prstGeom prst="rect">
-            <a:avLst/>
-          </a:prstGeom>
-          <a:noFill/>
-          <a:ln>
-            <a:noFill/>
-          </a:ln>
-        </p:spPr>
-        <p:txBody>
-          <a:bodyPr wrap="square" lIns="0" tIns="0" rIns="0" bIns="0" anchor="ctr"/>
-          <a:lstStyle/>
-          <a:p>
-            <a:pPr algn="l">
-              <a:spcAft>
-                <a:spcPts val="300"/>
-              </a:spcAft>
-            </a:pPr>
-            <a:r>
-              <a:rPr lang="en-GB" sz="1800" b="1" dirty="0">
-                <a:solidFill>
-                  <a:srgbClr val="1A2744"/>
-                </a:solidFill>
-                <a:latin typeface="Raleway"/>
-              </a:rPr>
-              <a:t>Built-in Consistency</a:t>
-            </a:r>
-          </a:p>
-          <a:p>
-            <a:pPr algn="l"/>
-            <a:r>
-              <a:rPr lang="en-GB" sz="1400" dirty="0">
-                <a:solidFill>
-                  <a:srgbClr val="4A5568"/>
-                </a:solidFill>
-                <a:latin typeface="Source Sans Pro"/>
-              </a:rPr>
-              <a:t>Same methods, every time. For tracking studies, results stay comparable across waves.</a:t>
-            </a:r>
-          </a:p>
-        </p:txBody>
-      </p:sp>
-      <p:sp>
-        <p:nvSpPr>
-          <p:cNvPr id="140" name="Call"/>
-          <p:cNvSpPr/>
-          <p:nvPr/>
-        </p:nvSpPr>
-        <p:spPr>
-          <a:xfrm>
-            <a:off x="762000" y="5334000"/>
-            <a:ext cx="10668000" cy="889000"/>
-          </a:xfrm>
-          <a:prstGeom prst="roundRect">
-            <a:avLst>
-              <a:gd name="adj" fmla="val 12000"/>
-            </a:avLst>
-          </a:prstGeom>
-          <a:solidFill>
-            <a:srgbClr val="323367"/>
-          </a:solidFill>
-          <a:ln>
-            <a:noFill/>
-          </a:ln>
-        </p:spPr>
-        <p:txBody>
-          <a:bodyPr wrap="square" lIns="182880" tIns="45720" rIns="182880" bIns="45720" anchor="ctr"/>
-          <a:lstStyle/>
-          <a:p>
-            <a:pPr algn="ctr"/>
-            <a:r>
-              <a:rPr lang="en-GB" sz="1600" i="1" dirty="0">
-                <a:solidFill>
-                  <a:srgbClr val="CC9900"/>
-                </a:solidFill>
-                <a:latin typeface="Source Sans Pro"/>
-              </a:rPr>
               <a:t>Controlled computational environment. Reproducible results. Every time.</a:t>
             </a:r>
-          </a:p>
-        </p:txBody>
-      </p:sp>
-      <p:sp>
-        <p:nvSpPr>
-          <p:cNvPr id="150" name="BA"/>
-          <p:cNvSpPr/>
-          <p:nvPr/>
-        </p:nvSpPr>
-        <p:spPr>
-          <a:xfrm>
-            <a:off x="0" y="6807200"/>
-            <a:ext cx="12192000" cy="50800"/>
-          </a:xfrm>
-          <a:prstGeom prst="rect">
-            <a:avLst/>
-          </a:prstGeom>
-          <a:solidFill>
-            <a:srgbClr val="CC9900"/>
-          </a:solidFill>
-          <a:ln>
-            <a:noFill/>
-          </a:ln>
-        </p:spPr>
-        <p:txBody>
-          <a:bodyPr/>
-          <a:lstStyle/>
-          <a:p>
-            <a:endParaRPr lang="en-GB"/>
           </a:p>
         </p:txBody>
       </p:sp>
     </p:spTree>
     <p:extLst>
       <p:ext uri="{BB962C8B-B14F-4D97-AF65-F5344CB8AC3E}">
-        <p14:creationId xmlns:p14="http://schemas.microsoft.com/office/powerpoint/2010/main" val="1487577956"/>
+        <p14:creationId xmlns:p14="http://schemas.microsoft.com/office/powerpoint/2010/main" val="3920869038"/>
       </p:ext>
     </p:extLst>
   </p:cSld>
@@ -17269,51 +17531,6 @@
       </p:sp>
       <p:sp>
         <p:nvSpPr>
-          <p:cNvPr id="104" name="Title"/>
-          <p:cNvSpPr/>
-          <p:nvPr/>
-        </p:nvSpPr>
-        <p:spPr>
-          <a:xfrm>
-            <a:off x="762000" y="609600"/>
-            <a:ext cx="8890000" cy="762000"/>
-          </a:xfrm>
-          <a:prstGeom prst="rect">
-            <a:avLst/>
-          </a:prstGeom>
-          <a:noFill/>
-          <a:ln>
-            <a:noFill/>
-          </a:ln>
-        </p:spPr>
-        <p:txBody>
-          <a:bodyPr wrap="square" lIns="0" tIns="0" rIns="0" bIns="0" anchor="t"/>
-          <a:lstStyle/>
-          <a:p>
-            <a:pPr algn="l"/>
-            <a:r>
-              <a:rPr lang="en-GB" sz="2800" b="1" dirty="0">
-                <a:solidFill>
-                  <a:srgbClr val="FFFFFF"/>
-                </a:solidFill>
-                <a:latin typeface="Raleway"/>
-              </a:rPr>
-              <a:t>Interactive Report, </a:t>
-            </a:r>
-            <a:r>
-              <a:rPr lang="en-GB" sz="2800" b="1" dirty="0">
-                <a:solidFill>
-                  <a:srgbClr val="CC9900"/>
-                </a:solidFill>
-                <a:latin typeface="Raleway"/>
-              </a:rPr>
-              <a:t>Not Static</a:t>
-            </a:r>
-          </a:p>
-        </p:txBody>
-      </p:sp>
-      <p:sp>
-        <p:nvSpPr>
           <p:cNvPr id="105" name="Num"/>
           <p:cNvSpPr/>
           <p:nvPr/>
@@ -17352,7 +17569,81 @@
       </p:sp>
       <p:sp>
         <p:nvSpPr>
-          <p:cNvPr id="106" name="MA"/>
+          <p:cNvPr id="150" name="BA"/>
+          <p:cNvSpPr/>
+          <p:nvPr/>
+        </p:nvSpPr>
+        <p:spPr>
+          <a:xfrm>
+            <a:off x="0" y="6807200"/>
+            <a:ext cx="12192000" cy="50800"/>
+          </a:xfrm>
+          <a:prstGeom prst="rect">
+            <a:avLst/>
+          </a:prstGeom>
+          <a:solidFill>
+            <a:srgbClr val="CC9900"/>
+          </a:solidFill>
+          <a:ln>
+            <a:noFill/>
+          </a:ln>
+        </p:spPr>
+        <p:txBody>
+          <a:bodyPr/>
+          <a:lstStyle/>
+          <a:p>
+            <a:endParaRPr lang="en-GB"/>
+          </a:p>
+        </p:txBody>
+      </p:sp>
+      <p:sp>
+        <p:nvSpPr>
+          <p:cNvPr id="104" name="Title"/>
+          <p:cNvSpPr/>
+          <p:nvPr/>
+        </p:nvSpPr>
+        <p:spPr>
+          <a:xfrm>
+            <a:off x="762000" y="533400"/>
+            <a:ext cx="9525000" cy="863600"/>
+          </a:xfrm>
+          <a:prstGeom prst="rect">
+            <a:avLst/>
+          </a:prstGeom>
+          <a:noFill/>
+          <a:ln>
+            <a:noFill/>
+          </a:ln>
+        </p:spPr>
+        <p:txBody>
+          <a:bodyPr wrap="square" lIns="0" tIns="0" rIns="0" bIns="0" anchor="b"/>
+          <a:lstStyle/>
+          <a:p>
+            <a:pPr algn="l"/>
+            <a:r>
+              <a:rPr lang="en-GB" sz="2800" b="1" dirty="0">
+                <a:solidFill>
+                  <a:srgbClr val="FFFFFF"/>
+                </a:solidFill>
+                <a:latin typeface="Raleway"/>
+              </a:rPr>
+              <a:t>Your Data, </a:t>
+            </a:r>
+            <a:r>
+              <a:rPr lang="en-GB" sz="2800" b="1" dirty="0">
+                <a:solidFill>
+                  <a:srgbClr val="CC9900"/>
+                </a:solidFill>
+                <a:latin typeface="Raleway"/>
+              </a:rPr>
+              <a:t>Alive</a:t>
+            </a:r>
+          </a:p>
+        </p:txBody>
+      </p:sp>
+      <p:sp>
+        <p:nvSpPr>
+          <p:cNvPr id="2" name="MA"/>
           <p:cNvSpPr/>
           <p:nvPr/>
         </p:nvSpPr>
@@ -17381,26 +17672,80 @@
       </p:sp>
       <p:sp>
         <p:nvSpPr>
-          <p:cNvPr id="110" name="FC0"/>
-          <p:cNvSpPr/>
-          <p:nvPr/>
-        </p:nvSpPr>
-        <p:spPr>
-          <a:xfrm>
-            <a:off x="762000" y="1905000"/>
-            <a:ext cx="10668000" cy="1079500"/>
+          <p:cNvPr id="106" name="Hero"/>
+          <p:cNvSpPr/>
+          <p:nvPr/>
+        </p:nvSpPr>
+        <p:spPr>
+          <a:xfrm>
+            <a:off x="762000" y="1841500"/>
+            <a:ext cx="10668000" cy="635000"/>
+          </a:xfrm>
+          <a:prstGeom prst="rect">
+            <a:avLst/>
+          </a:prstGeom>
+          <a:noFill/>
+          <a:ln>
+            <a:noFill/>
+          </a:ln>
+        </p:spPr>
+        <p:txBody>
+          <a:bodyPr wrap="square" lIns="0" tIns="0" rIns="0" bIns="0" anchor="t"/>
+          <a:lstStyle/>
+          <a:p>
+            <a:pPr algn="l"/>
+            <a:r>
+              <a:rPr lang="en-GB" sz="1600" dirty="0">
+                <a:solidFill>
+                  <a:srgbClr val="1A2744"/>
+                </a:solidFill>
+                <a:latin typeface="Source Sans Pro"/>
+              </a:rPr>
+              <a:t>A Turas report isn’t a flat file you scroll through. It’s an </a:t>
+            </a:r>
+            <a:r>
+              <a:rPr lang="en-GB" sz="1600" b="1" dirty="0">
+                <a:solidFill>
+                  <a:srgbClr val="1A2744"/>
+                </a:solidFill>
+                <a:latin typeface="Source Sans Pro"/>
+              </a:rPr>
+              <a:t>interactive experience</a:t>
+            </a:r>
+            <a:r>
+              <a:rPr lang="en-GB" sz="1600" dirty="0">
+                <a:solidFill>
+                  <a:srgbClr val="1A2744"/>
+                </a:solidFill>
+                <a:latin typeface="Source Sans Pro"/>
+              </a:rPr>
+              <a:t> — intuitive enough for anyone on your team to explore with minimal training.</a:t>
+            </a:r>
+          </a:p>
+        </p:txBody>
+      </p:sp>
+      <p:sp>
+        <p:nvSpPr>
+          <p:cNvPr id="107" name="StaticBG"/>
+          <p:cNvSpPr/>
+          <p:nvPr/>
+        </p:nvSpPr>
+        <p:spPr>
+          <a:xfrm>
+            <a:off x="762000" y="2667000"/>
+            <a:ext cx="5080000" cy="1968500"/>
           </a:xfrm>
           <a:prstGeom prst="roundRect">
             <a:avLst>
-              <a:gd name="adj" fmla="val 8000"/>
+              <a:gd name="adj" fmla="val 3000"/>
             </a:avLst>
           </a:prstGeom>
           <a:solidFill>
-            <a:srgbClr val="F5F7FA"/>
-          </a:solidFill>
-          <a:ln w="6350">
+            <a:srgbClr val="FFF5F5"/>
+          </a:solidFill>
+          <a:ln w="9525">
             <a:solidFill>
-              <a:srgbClr val="E2E8F0"/>
+              <a:srgbClr val="FED7D7"/>
             </a:solidFill>
           </a:ln>
         </p:spPr>
@@ -17414,45 +17759,14 @@
       </p:sp>
       <p:sp>
         <p:nvSpPr>
-          <p:cNvPr id="111" name="FA0"/>
-          <p:cNvSpPr/>
-          <p:nvPr/>
-        </p:nvSpPr>
-        <p:spPr>
-          <a:xfrm>
-            <a:off x="762000" y="1905000"/>
-            <a:ext cx="63500" cy="1079500"/>
-          </a:xfrm>
-          <a:prstGeom prst="roundRect">
-            <a:avLst>
-              <a:gd name="adj" fmla="val 50000"/>
-            </a:avLst>
-          </a:prstGeom>
-          <a:solidFill>
-            <a:srgbClr val="CC9900"/>
-          </a:solidFill>
-          <a:ln>
-            <a:noFill/>
-          </a:ln>
-        </p:spPr>
-        <p:txBody>
-          <a:bodyPr/>
-          <a:lstStyle/>
-          <a:p>
-            <a:endParaRPr lang="en-GB"/>
-          </a:p>
-        </p:txBody>
-      </p:sp>
-      <p:sp>
-        <p:nvSpPr>
-          <p:cNvPr id="112" name="FT0"/>
-          <p:cNvSpPr/>
-          <p:nvPr/>
-        </p:nvSpPr>
-        <p:spPr>
-          <a:xfrm>
-            <a:off x="1041400" y="2006600"/>
-            <a:ext cx="10160000" cy="876300"/>
+          <p:cNvPr id="108" name="StaticTxt"/>
+          <p:cNvSpPr/>
+          <p:nvPr/>
+        </p:nvSpPr>
+        <p:spPr>
+          <a:xfrm>
+            <a:off x="952500" y="2794000"/>
+            <a:ext cx="4699000" cy="1714500"/>
           </a:xfrm>
           <a:prstGeom prst="rect">
             <a:avLst/>
@@ -17463,8 +17777,24 @@
           </a:ln>
         </p:spPr>
         <p:txBody>
-          <a:bodyPr wrap="square" lIns="0" tIns="0" rIns="0" bIns="0" anchor="ctr"/>
-          <a:lstStyle/>
+          <a:bodyPr wrap="square" lIns="0" tIns="0" rIns="0" bIns="0" anchor="t"/>
+          <a:lstStyle/>
+          <a:p>
+            <a:pPr algn="l">
+              <a:spcAft>
+                <a:spcPts val="400"/>
+              </a:spcAft>
+            </a:pPr>
+            <a:r>
+              <a:rPr lang="en-GB" sz="1600" b="1" dirty="0">
+                <a:solidFill>
+                  <a:srgbClr val="C53030"/>
+                </a:solidFill>
+                <a:latin typeface="Raleway"/>
+              </a:rPr>
+              <a:t>Static PPT / PDF</a:t>
+            </a:r>
+          </a:p>
           <a:p>
             <a:pPr algn="l">
               <a:spcAft>
@@ -17472,115 +17802,15 @@
               </a:spcAft>
             </a:pPr>
             <a:r>
-              <a:rPr lang="en-GB" sz="1800" b="1" dirty="0">
-                <a:solidFill>
-                  <a:srgbClr val="1A2744"/>
-                </a:solidFill>
-                <a:latin typeface="Raleway"/>
-              </a:rPr>
-              <a:t>Browser-Based</a:t>
-            </a:r>
-          </a:p>
-          <a:p>
-            <a:pPr algn="l"/>
-            <a:r>
-              <a:rPr lang="en-GB" sz="1400" dirty="0">
+              <a:rPr lang="en-GB" sz="1200" dirty="0">
                 <a:solidFill>
                   <a:srgbClr val="4A5568"/>
                 </a:solidFill>
                 <a:latin typeface="Source Sans Pro"/>
               </a:rPr>
-              <a:t>Runs in any modern browser. Nothing to install, no subscription, no licence to manage.</a:t>
-            </a:r>
-          </a:p>
-        </p:txBody>
-      </p:sp>
-      <p:sp>
-        <p:nvSpPr>
-          <p:cNvPr id="113" name="FC1"/>
-          <p:cNvSpPr/>
-          <p:nvPr/>
-        </p:nvSpPr>
-        <p:spPr>
-          <a:xfrm>
-            <a:off x="762000" y="3175000"/>
-            <a:ext cx="10668000" cy="1079500"/>
-          </a:xfrm>
-          <a:prstGeom prst="roundRect">
-            <a:avLst>
-              <a:gd name="adj" fmla="val 8000"/>
-            </a:avLst>
-          </a:prstGeom>
-          <a:solidFill>
-            <a:srgbClr val="F5F7FA"/>
-          </a:solidFill>
-          <a:ln w="6350">
-            <a:solidFill>
-              <a:srgbClr val="E2E8F0"/>
-            </a:solidFill>
-          </a:ln>
-        </p:spPr>
-        <p:txBody>
-          <a:bodyPr/>
-          <a:lstStyle/>
-          <a:p>
-            <a:endParaRPr lang="en-GB"/>
-          </a:p>
-        </p:txBody>
-      </p:sp>
-      <p:sp>
-        <p:nvSpPr>
-          <p:cNvPr id="114" name="FA1"/>
-          <p:cNvSpPr/>
-          <p:nvPr/>
-        </p:nvSpPr>
-        <p:spPr>
-          <a:xfrm>
-            <a:off x="762000" y="3175000"/>
-            <a:ext cx="63500" cy="1079500"/>
-          </a:xfrm>
-          <a:prstGeom prst="roundRect">
-            <a:avLst>
-              <a:gd name="adj" fmla="val 50000"/>
-            </a:avLst>
-          </a:prstGeom>
-          <a:solidFill>
-            <a:srgbClr val="4A90D9"/>
-          </a:solidFill>
-          <a:ln>
-            <a:noFill/>
-          </a:ln>
-        </p:spPr>
-        <p:txBody>
-          <a:bodyPr/>
-          <a:lstStyle/>
-          <a:p>
-            <a:endParaRPr lang="en-GB"/>
-          </a:p>
-        </p:txBody>
-      </p:sp>
-      <p:sp>
-        <p:nvSpPr>
-          <p:cNvPr id="115" name="FT1"/>
-          <p:cNvSpPr/>
-          <p:nvPr/>
-        </p:nvSpPr>
-        <p:spPr>
-          <a:xfrm>
-            <a:off x="1041400" y="3276600"/>
-            <a:ext cx="10160000" cy="876300"/>
-          </a:xfrm>
-          <a:prstGeom prst="rect">
-            <a:avLst/>
-          </a:prstGeom>
-          <a:noFill/>
-          <a:ln>
-            <a:noFill/>
-          </a:ln>
-        </p:spPr>
-        <p:txBody>
-          <a:bodyPr wrap="square" lIns="0" tIns="0" rIns="0" bIns="0" anchor="ctr"/>
-          <a:lstStyle/>
+              <a:t>✘  Fixed views — what you see is all you get</a:t>
+            </a:r>
+          </a:p>
           <a:p>
             <a:pPr algn="l">
               <a:spcAft>
@@ -17588,115 +17818,15 @@
               </a:spcAft>
             </a:pPr>
             <a:r>
-              <a:rPr lang="en-GB" sz="1800" b="1" dirty="0">
-                <a:solidFill>
-                  <a:srgbClr val="1A2744"/>
-                </a:solidFill>
-                <a:latin typeface="Raleway"/>
-              </a:rPr>
-              <a:t>Single Source of Truth</a:t>
-            </a:r>
-          </a:p>
-          <a:p>
-            <a:pPr algn="l"/>
-            <a:r>
-              <a:rPr lang="en-GB" sz="1400" dirty="0">
+              <a:rPr lang="en-GB" sz="1200" dirty="0">
                 <a:solidFill>
                   <a:srgbClr val="4A5568"/>
                 </a:solidFill>
                 <a:latin typeface="Source Sans Pro"/>
               </a:rPr>
-              <a:t>Browse all tables, switch between table and chart views, cut by any segment — without waiting for the analyst.</a:t>
-            </a:r>
-          </a:p>
-        </p:txBody>
-      </p:sp>
-      <p:sp>
-        <p:nvSpPr>
-          <p:cNvPr id="116" name="FC2"/>
-          <p:cNvSpPr/>
-          <p:nvPr/>
-        </p:nvSpPr>
-        <p:spPr>
-          <a:xfrm>
-            <a:off x="762000" y="4445000"/>
-            <a:ext cx="10668000" cy="1079500"/>
-          </a:xfrm>
-          <a:prstGeom prst="roundRect">
-            <a:avLst>
-              <a:gd name="adj" fmla="val 8000"/>
-            </a:avLst>
-          </a:prstGeom>
-          <a:solidFill>
-            <a:srgbClr val="F5F7FA"/>
-          </a:solidFill>
-          <a:ln w="6350">
-            <a:solidFill>
-              <a:srgbClr val="E2E8F0"/>
-            </a:solidFill>
-          </a:ln>
-        </p:spPr>
-        <p:txBody>
-          <a:bodyPr/>
-          <a:lstStyle/>
-          <a:p>
-            <a:endParaRPr lang="en-GB"/>
-          </a:p>
-        </p:txBody>
-      </p:sp>
-      <p:sp>
-        <p:nvSpPr>
-          <p:cNvPr id="117" name="FA2"/>
-          <p:cNvSpPr/>
-          <p:nvPr/>
-        </p:nvSpPr>
-        <p:spPr>
-          <a:xfrm>
-            <a:off x="762000" y="4445000"/>
-            <a:ext cx="63500" cy="1079500"/>
-          </a:xfrm>
-          <a:prstGeom prst="roundRect">
-            <a:avLst>
-              <a:gd name="adj" fmla="val 50000"/>
-            </a:avLst>
-          </a:prstGeom>
-          <a:solidFill>
-            <a:srgbClr val="7C5CFC"/>
-          </a:solidFill>
-          <a:ln>
-            <a:noFill/>
-          </a:ln>
-        </p:spPr>
-        <p:txBody>
-          <a:bodyPr/>
-          <a:lstStyle/>
-          <a:p>
-            <a:endParaRPr lang="en-GB"/>
-          </a:p>
-        </p:txBody>
-      </p:sp>
-      <p:sp>
-        <p:nvSpPr>
-          <p:cNvPr id="118" name="FT2"/>
-          <p:cNvSpPr/>
-          <p:nvPr/>
-        </p:nvSpPr>
-        <p:spPr>
-          <a:xfrm>
-            <a:off x="1041400" y="4546600"/>
-            <a:ext cx="10160000" cy="876300"/>
-          </a:xfrm>
-          <a:prstGeom prst="rect">
-            <a:avLst/>
-          </a:prstGeom>
-          <a:noFill/>
-          <a:ln>
-            <a:noFill/>
-          </a:ln>
-        </p:spPr>
-        <p:txBody>
-          <a:bodyPr wrap="square" lIns="0" tIns="0" rIns="0" bIns="0" anchor="ctr"/>
-          <a:lstStyle/>
+              <a:t>✘  New question? Ask the analyst, wait days</a:t>
+            </a:r>
+          </a:p>
           <a:p>
             <a:pPr algn="l">
               <a:spcAft>
@@ -17704,98 +17834,548 @@
               </a:spcAft>
             </a:pPr>
             <a:r>
-              <a:rPr lang="en-GB" sz="1800" b="1" dirty="0">
+              <a:rPr lang="en-GB" sz="1200" dirty="0">
+                <a:solidFill>
+                  <a:srgbClr val="4A5568"/>
+                </a:solidFill>
+                <a:latin typeface="Source Sans Pro"/>
+              </a:rPr>
+              <a:t>✘  Sits on a shared drive, rarely reopened</a:t>
+            </a:r>
+          </a:p>
+          <a:p>
+            <a:pPr algn="l"/>
+            <a:r>
+              <a:rPr lang="en-GB" sz="1200" dirty="0">
+                <a:solidFill>
+                  <a:srgbClr val="4A5568"/>
+                </a:solidFill>
+                <a:latin typeface="Source Sans Pro"/>
+              </a:rPr>
+              <a:t>✘  One person’s interpretation, locked in</a:t>
+            </a:r>
+          </a:p>
+        </p:txBody>
+      </p:sp>
+      <p:sp>
+        <p:nvSpPr>
+          <p:cNvPr id="109" name="TurasBG"/>
+          <p:cNvSpPr/>
+          <p:nvPr/>
+        </p:nvSpPr>
+        <p:spPr>
+          <a:xfrm>
+            <a:off x="6350000" y="2667000"/>
+            <a:ext cx="5080000" cy="1968500"/>
+          </a:xfrm>
+          <a:prstGeom prst="roundRect">
+            <a:avLst>
+              <a:gd name="adj" fmla="val 3000"/>
+            </a:avLst>
+          </a:prstGeom>
+          <a:solidFill>
+            <a:srgbClr val="FFFFF0"/>
+          </a:solidFill>
+          <a:ln w="9525">
+            <a:solidFill>
+              <a:srgbClr val="FEFCBF"/>
+            </a:solidFill>
+          </a:ln>
+        </p:spPr>
+        <p:txBody>
+          <a:bodyPr/>
+          <a:lstStyle/>
+          <a:p>
+            <a:endParaRPr lang="en-GB"/>
+          </a:p>
+        </p:txBody>
+      </p:sp>
+      <p:sp>
+        <p:nvSpPr>
+          <p:cNvPr id="110" name="TurasTxt"/>
+          <p:cNvSpPr/>
+          <p:nvPr/>
+        </p:nvSpPr>
+        <p:spPr>
+          <a:xfrm>
+            <a:off x="6540500" y="2794000"/>
+            <a:ext cx="4699000" cy="1714500"/>
+          </a:xfrm>
+          <a:prstGeom prst="rect">
+            <a:avLst/>
+          </a:prstGeom>
+          <a:noFill/>
+          <a:ln>
+            <a:noFill/>
+          </a:ln>
+        </p:spPr>
+        <p:txBody>
+          <a:bodyPr wrap="square" lIns="0" tIns="0" rIns="0" bIns="0" anchor="t"/>
+          <a:lstStyle/>
+          <a:p>
+            <a:pPr algn="l">
+              <a:spcAft>
+                <a:spcPts val="400"/>
+              </a:spcAft>
+            </a:pPr>
+            <a:r>
+              <a:rPr lang="en-GB" sz="1600" b="1" dirty="0">
+                <a:solidFill>
+                  <a:srgbClr val="CC9900"/>
+                </a:solidFill>
+                <a:latin typeface="Raleway"/>
+              </a:rPr>
+              <a:t>Turas Interactive Report</a:t>
+            </a:r>
+          </a:p>
+          <a:p>
+            <a:pPr algn="l">
+              <a:spcAft>
+                <a:spcPts val="200"/>
+              </a:spcAft>
+            </a:pPr>
+            <a:r>
+              <a:rPr lang="en-GB" sz="1200" dirty="0">
+                <a:solidFill>
+                  <a:srgbClr val="4A5568"/>
+                </a:solidFill>
+                <a:latin typeface="Source Sans Pro"/>
+              </a:rPr>
+              <a:t>✔  Explore every cut, filter, and chart on demand</a:t>
+            </a:r>
+          </a:p>
+          <a:p>
+            <a:pPr algn="l">
+              <a:spcAft>
+                <a:spcPts val="200"/>
+              </a:spcAft>
+            </a:pPr>
+            <a:r>
+              <a:rPr lang="en-GB" sz="1200" dirty="0">
+                <a:solidFill>
+                  <a:srgbClr val="4A5568"/>
+                </a:solidFill>
+                <a:latin typeface="Source Sans Pro"/>
+              </a:rPr>
+              <a:t>✔  Answer your own follow-up questions instantly</a:t>
+            </a:r>
+          </a:p>
+          <a:p>
+            <a:pPr algn="l">
+              <a:spcAft>
+                <a:spcPts val="200"/>
+              </a:spcAft>
+            </a:pPr>
+            <a:r>
+              <a:rPr lang="en-GB" sz="1200" dirty="0">
+                <a:solidFill>
+                  <a:srgbClr val="4A5568"/>
+                </a:solidFill>
+                <a:latin typeface="Source Sans Pro"/>
+              </a:rPr>
+              <a:t>✔  Share one file — the whole team has access</a:t>
+            </a:r>
+          </a:p>
+          <a:p>
+            <a:pPr algn="l"/>
+            <a:r>
+              <a:rPr lang="en-GB" sz="1200" dirty="0">
+                <a:solidFill>
+                  <a:srgbClr val="4A5568"/>
+                </a:solidFill>
+                <a:latin typeface="Source Sans Pro"/>
+              </a:rPr>
+              <a:t>✔  So intuitive, minimal training needed</a:t>
+            </a:r>
+          </a:p>
+        </p:txBody>
+      </p:sp>
+      <p:sp>
+        <p:nvSpPr>
+          <p:cNvPr id="111" name="Fact0BG"/>
+          <p:cNvSpPr/>
+          <p:nvPr/>
+        </p:nvSpPr>
+        <p:spPr>
+          <a:xfrm>
+            <a:off x="762000" y="4889500"/>
+            <a:ext cx="3454400" cy="825500"/>
+          </a:xfrm>
+          <a:prstGeom prst="roundRect">
+            <a:avLst>
+              <a:gd name="adj" fmla="val 5000"/>
+            </a:avLst>
+          </a:prstGeom>
+          <a:solidFill>
+            <a:srgbClr val="F5F7FA"/>
+          </a:solidFill>
+          <a:ln w="6350">
+            <a:solidFill>
+              <a:srgbClr val="E2E8F0"/>
+            </a:solidFill>
+          </a:ln>
+        </p:spPr>
+        <p:txBody>
+          <a:bodyPr/>
+          <a:lstStyle/>
+          <a:p>
+            <a:endParaRPr lang="en-GB"/>
+          </a:p>
+        </p:txBody>
+      </p:sp>
+      <p:sp>
+        <p:nvSpPr>
+          <p:cNvPr id="112" name="Fact0Acc"/>
+          <p:cNvSpPr/>
+          <p:nvPr/>
+        </p:nvSpPr>
+        <p:spPr>
+          <a:xfrm>
+            <a:off x="914400" y="4889500"/>
+            <a:ext cx="444500" cy="38100"/>
+          </a:xfrm>
+          <a:prstGeom prst="rect">
+            <a:avLst/>
+          </a:prstGeom>
+          <a:solidFill>
+            <a:srgbClr val="4A90D9"/>
+          </a:solidFill>
+          <a:ln>
+            <a:noFill/>
+          </a:ln>
+        </p:spPr>
+        <p:txBody>
+          <a:bodyPr/>
+          <a:lstStyle/>
+          <a:p>
+            <a:endParaRPr lang="en-GB"/>
+          </a:p>
+        </p:txBody>
+      </p:sp>
+      <p:sp>
+        <p:nvSpPr>
+          <p:cNvPr id="113" name="Fact0Txt"/>
+          <p:cNvSpPr/>
+          <p:nvPr/>
+        </p:nvSpPr>
+        <p:spPr>
+          <a:xfrm>
+            <a:off x="914400" y="4991100"/>
+            <a:ext cx="3149600" cy="622300"/>
+          </a:xfrm>
+          <a:prstGeom prst="rect">
+            <a:avLst/>
+          </a:prstGeom>
+          <a:noFill/>
+          <a:ln>
+            <a:noFill/>
+          </a:ln>
+        </p:spPr>
+        <p:txBody>
+          <a:bodyPr wrap="square" lIns="0" tIns="0" rIns="0" bIns="0" anchor="t"/>
+          <a:lstStyle/>
+          <a:p>
+            <a:pPr algn="l">
+              <a:spcAft>
+                <a:spcPts val="100"/>
+              </a:spcAft>
+            </a:pPr>
+            <a:r>
+              <a:rPr lang="en-GB" sz="1400" b="1" dirty="0">
                 <a:solidFill>
                   <a:srgbClr val="1A2744"/>
                 </a:solidFill>
                 <a:latin typeface="Raleway"/>
               </a:rPr>
+              <a:t>Browser-Based</a:t>
+            </a:r>
+          </a:p>
+          <a:p>
+            <a:pPr algn="l"/>
+            <a:r>
+              <a:rPr lang="en-GB" sz="1100" dirty="0">
+                <a:solidFill>
+                  <a:srgbClr val="4A5568"/>
+                </a:solidFill>
+                <a:latin typeface="Source Sans Pro"/>
+              </a:rPr>
+              <a:t>Nothing to install. Open a link and go.</a:t>
+            </a:r>
+          </a:p>
+        </p:txBody>
+      </p:sp>
+      <p:sp>
+        <p:nvSpPr>
+          <p:cNvPr id="114" name="Fact1BG"/>
+          <p:cNvSpPr/>
+          <p:nvPr/>
+        </p:nvSpPr>
+        <p:spPr>
+          <a:xfrm>
+            <a:off x="4368800" y="4889500"/>
+            <a:ext cx="3454400" cy="825500"/>
+          </a:xfrm>
+          <a:prstGeom prst="roundRect">
+            <a:avLst>
+              <a:gd name="adj" fmla="val 5000"/>
+            </a:avLst>
+          </a:prstGeom>
+          <a:solidFill>
+            <a:srgbClr val="F5F7FA"/>
+          </a:solidFill>
+          <a:ln w="6350">
+            <a:solidFill>
+              <a:srgbClr val="E2E8F0"/>
+            </a:solidFill>
+          </a:ln>
+        </p:spPr>
+        <p:txBody>
+          <a:bodyPr/>
+          <a:lstStyle/>
+          <a:p>
+            <a:endParaRPr lang="en-GB"/>
+          </a:p>
+        </p:txBody>
+      </p:sp>
+      <p:sp>
+        <p:nvSpPr>
+          <p:cNvPr id="115" name="Fact1Acc"/>
+          <p:cNvSpPr/>
+          <p:nvPr/>
+        </p:nvSpPr>
+        <p:spPr>
+          <a:xfrm>
+            <a:off x="4521200" y="4889500"/>
+            <a:ext cx="444500" cy="38100"/>
+          </a:xfrm>
+          <a:prstGeom prst="rect">
+            <a:avLst/>
+          </a:prstGeom>
+          <a:solidFill>
+            <a:srgbClr val="CC9900"/>
+          </a:solidFill>
+          <a:ln>
+            <a:noFill/>
+          </a:ln>
+        </p:spPr>
+        <p:txBody>
+          <a:bodyPr/>
+          <a:lstStyle/>
+          <a:p>
+            <a:endParaRPr lang="en-GB"/>
+          </a:p>
+        </p:txBody>
+      </p:sp>
+      <p:sp>
+        <p:nvSpPr>
+          <p:cNvPr id="116" name="Fact1Txt"/>
+          <p:cNvSpPr/>
+          <p:nvPr/>
+        </p:nvSpPr>
+        <p:spPr>
+          <a:xfrm>
+            <a:off x="4521200" y="4991100"/>
+            <a:ext cx="3149600" cy="622300"/>
+          </a:xfrm>
+          <a:prstGeom prst="rect">
+            <a:avLst/>
+          </a:prstGeom>
+          <a:noFill/>
+          <a:ln>
+            <a:noFill/>
+          </a:ln>
+        </p:spPr>
+        <p:txBody>
+          <a:bodyPr wrap="square" lIns="0" tIns="0" rIns="0" bIns="0" anchor="t"/>
+          <a:lstStyle/>
+          <a:p>
+            <a:pPr algn="l">
+              <a:spcAft>
+                <a:spcPts val="100"/>
+              </a:spcAft>
+            </a:pPr>
+            <a:r>
+              <a:rPr lang="en-GB" sz="1400" b="1" dirty="0">
+                <a:solidFill>
+                  <a:srgbClr val="1A2744"/>
+                </a:solidFill>
+                <a:latin typeface="Raleway"/>
+              </a:rPr>
+              <a:t>Table + Chart Views</a:t>
+            </a:r>
+          </a:p>
+          <a:p>
+            <a:pPr algn="l"/>
+            <a:r>
+              <a:rPr lang="en-GB" sz="1100" dirty="0">
+                <a:solidFill>
+                  <a:srgbClr val="4A5568"/>
+                </a:solidFill>
+                <a:latin typeface="Source Sans Pro"/>
+              </a:rPr>
+              <a:t>Switch between views with one click.</a:t>
+            </a:r>
+          </a:p>
+        </p:txBody>
+      </p:sp>
+      <p:sp>
+        <p:nvSpPr>
+          <p:cNvPr id="117" name="Fact2BG"/>
+          <p:cNvSpPr/>
+          <p:nvPr/>
+        </p:nvSpPr>
+        <p:spPr>
+          <a:xfrm>
+            <a:off x="7975600" y="4889500"/>
+            <a:ext cx="3454400" cy="825500"/>
+          </a:xfrm>
+          <a:prstGeom prst="roundRect">
+            <a:avLst>
+              <a:gd name="adj" fmla="val 5000"/>
+            </a:avLst>
+          </a:prstGeom>
+          <a:solidFill>
+            <a:srgbClr val="F5F7FA"/>
+          </a:solidFill>
+          <a:ln w="6350">
+            <a:solidFill>
+              <a:srgbClr val="E2E8F0"/>
+            </a:solidFill>
+          </a:ln>
+        </p:spPr>
+        <p:txBody>
+          <a:bodyPr/>
+          <a:lstStyle/>
+          <a:p>
+            <a:endParaRPr lang="en-GB"/>
+          </a:p>
+        </p:txBody>
+      </p:sp>
+      <p:sp>
+        <p:nvSpPr>
+          <p:cNvPr id="118" name="Fact2Acc"/>
+          <p:cNvSpPr/>
+          <p:nvPr/>
+        </p:nvSpPr>
+        <p:spPr>
+          <a:xfrm>
+            <a:off x="8128000" y="4889500"/>
+            <a:ext cx="444500" cy="38100"/>
+          </a:xfrm>
+          <a:prstGeom prst="rect">
+            <a:avLst/>
+          </a:prstGeom>
+          <a:solidFill>
+            <a:srgbClr val="E56B33"/>
+          </a:solidFill>
+          <a:ln>
+            <a:noFill/>
+          </a:ln>
+        </p:spPr>
+        <p:txBody>
+          <a:bodyPr/>
+          <a:lstStyle/>
+          <a:p>
+            <a:endParaRPr lang="en-GB"/>
+          </a:p>
+        </p:txBody>
+      </p:sp>
+      <p:sp>
+        <p:nvSpPr>
+          <p:cNvPr id="119" name="Fact2Txt"/>
+          <p:cNvSpPr/>
+          <p:nvPr/>
+        </p:nvSpPr>
+        <p:spPr>
+          <a:xfrm>
+            <a:off x="8128000" y="4991100"/>
+            <a:ext cx="3149600" cy="622300"/>
+          </a:xfrm>
+          <a:prstGeom prst="rect">
+            <a:avLst/>
+          </a:prstGeom>
+          <a:noFill/>
+          <a:ln>
+            <a:noFill/>
+          </a:ln>
+        </p:spPr>
+        <p:txBody>
+          <a:bodyPr wrap="square" lIns="0" tIns="0" rIns="0" bIns="0" anchor="t"/>
+          <a:lstStyle/>
+          <a:p>
+            <a:pPr algn="l">
+              <a:spcAft>
+                <a:spcPts val="100"/>
+              </a:spcAft>
+            </a:pPr>
+            <a:r>
+              <a:rPr lang="en-GB" sz="1400" b="1" dirty="0">
+                <a:solidFill>
+                  <a:srgbClr val="1A2744"/>
+                </a:solidFill>
+                <a:latin typeface="Raleway"/>
+              </a:rPr>
               <a:t>Excel Export</a:t>
             </a:r>
           </a:p>
           <a:p>
             <a:pPr algn="l"/>
             <a:r>
-              <a:rPr lang="en-GB" sz="1400" dirty="0">
+              <a:rPr lang="en-GB" sz="1100" dirty="0">
                 <a:solidFill>
                   <a:srgbClr val="4A5568"/>
                 </a:solidFill>
                 <a:latin typeface="Source Sans Pro"/>
               </a:rPr>
-              <a:t>Tables can be exported to Excel at any point, fitting into existing workflows.</a:t>
-            </a:r>
-          </a:p>
-        </p:txBody>
-      </p:sp>
-      <p:sp>
-        <p:nvSpPr>
-          <p:cNvPr id="140" name="Tag2"/>
-          <p:cNvSpPr/>
-          <p:nvPr/>
-        </p:nvSpPr>
-        <p:spPr>
-          <a:xfrm>
-            <a:off x="762000" y="5969000"/>
-            <a:ext cx="10668000" cy="381000"/>
-          </a:xfrm>
-          <a:prstGeom prst="rect">
-            <a:avLst/>
-          </a:prstGeom>
-          <a:noFill/>
-          <a:ln>
-            <a:noFill/>
-          </a:ln>
-        </p:spPr>
-        <p:txBody>
-          <a:bodyPr wrap="square" lIns="0" tIns="0" rIns="0" bIns="0" anchor="ctr"/>
-          <a:lstStyle/>
-          <a:p>
-            <a:pPr algn="l"/>
-            <a:r>
-              <a:rPr lang="en-GB" sz="1400" dirty="0">
-                <a:solidFill>
-                  <a:srgbClr val="FFFFFF"/>
+              <a:t>Pull any table into Excel whenever you need it.</a:t>
+            </a:r>
+          </a:p>
+        </p:txBody>
+      </p:sp>
+      <p:sp>
+        <p:nvSpPr>
+          <p:cNvPr id="120" name="Call"/>
+          <p:cNvSpPr/>
+          <p:nvPr/>
+        </p:nvSpPr>
+        <p:spPr>
+          <a:xfrm>
+            <a:off x="762000" y="5905500"/>
+            <a:ext cx="10668000" cy="635000"/>
+          </a:xfrm>
+          <a:prstGeom prst="roundRect">
+            <a:avLst>
+              <a:gd name="adj" fmla="val 10000"/>
+            </a:avLst>
+          </a:prstGeom>
+          <a:solidFill>
+            <a:srgbClr val="323367"/>
+          </a:solidFill>
+          <a:ln>
+            <a:noFill/>
+          </a:ln>
+        </p:spPr>
+        <p:txBody>
+          <a:bodyPr wrap="square" lIns="72000" tIns="36000" rIns="72000" bIns="36000" anchor="ctr"/>
+          <a:lstStyle/>
+          <a:p>
+            <a:pPr algn="ctr"/>
+            <a:r>
+              <a:rPr lang="en-GB" sz="1400" i="1" dirty="0">
+                <a:solidFill>
+                  <a:srgbClr val="CC9900"/>
                 </a:solidFill>
                 <a:latin typeface="Source Sans Pro"/>
               </a:rPr>
-              <a:t>Zero installation  |  Zero subscriptions  |  Zero licence management</a:t>
-            </a:r>
-          </a:p>
-        </p:txBody>
-      </p:sp>
-      <p:sp>
-        <p:nvSpPr>
-          <p:cNvPr id="150" name="BA"/>
-          <p:cNvSpPr/>
-          <p:nvPr/>
-        </p:nvSpPr>
-        <p:spPr>
-          <a:xfrm>
-            <a:off x="0" y="6807200"/>
-            <a:ext cx="12192000" cy="50800"/>
-          </a:xfrm>
-          <a:prstGeom prst="rect">
-            <a:avLst/>
-          </a:prstGeom>
-          <a:solidFill>
-            <a:srgbClr val="CC9900"/>
-          </a:solidFill>
-          <a:ln>
-            <a:noFill/>
-          </a:ln>
-        </p:spPr>
-        <p:txBody>
-          <a:bodyPr/>
-          <a:lstStyle/>
-          <a:p>
-            <a:endParaRPr lang="en-GB"/>
+              <a:t>Not a dashboard. Not a PDF. A living report your whole team can explore.</a:t>
+            </a:r>
           </a:p>
         </p:txBody>
       </p:sp>
     </p:spTree>
     <p:extLst>
       <p:ext uri="{BB962C8B-B14F-4D97-AF65-F5344CB8AC3E}">
-        <p14:creationId xmlns:p14="http://schemas.microsoft.com/office/powerpoint/2010/main" val="747300282"/>
+        <p14:creationId xmlns:p14="http://schemas.microsoft.com/office/powerpoint/2010/main" val="3254322546"/>
       </p:ext>
     </p:extLst>
   </p:cSld>
@@ -17969,51 +18549,6 @@
       </p:sp>
       <p:sp>
         <p:nvSpPr>
-          <p:cNvPr id="104" name="Title"/>
-          <p:cNvSpPr/>
-          <p:nvPr/>
-        </p:nvSpPr>
-        <p:spPr>
-          <a:xfrm>
-            <a:off x="762000" y="609600"/>
-            <a:ext cx="8890000" cy="762000"/>
-          </a:xfrm>
-          <a:prstGeom prst="rect">
-            <a:avLst/>
-          </a:prstGeom>
-          <a:noFill/>
-          <a:ln>
-            <a:noFill/>
-          </a:ln>
-        </p:spPr>
-        <p:txBody>
-          <a:bodyPr wrap="square" lIns="0" tIns="0" rIns="0" bIns="0" anchor="t"/>
-          <a:lstStyle/>
-          <a:p>
-            <a:pPr algn="l"/>
-            <a:r>
-              <a:rPr lang="en-GB" sz="2800" b="1" dirty="0">
-                <a:solidFill>
-                  <a:srgbClr val="FFFFFF"/>
-                </a:solidFill>
-                <a:latin typeface="Raleway"/>
-              </a:rPr>
-              <a:t>From Exploration </a:t>
-            </a:r>
-            <a:r>
-              <a:rPr lang="en-GB" sz="2800" b="1" dirty="0">
-                <a:solidFill>
-                  <a:srgbClr val="CC9900"/>
-                </a:solidFill>
-                <a:latin typeface="Raleway"/>
-              </a:rPr>
-              <a:t>to Presentation</a:t>
-            </a:r>
-          </a:p>
-        </p:txBody>
-      </p:sp>
-      <p:sp>
-        <p:nvSpPr>
           <p:cNvPr id="105" name="Num"/>
           <p:cNvSpPr/>
           <p:nvPr/>
@@ -18052,7 +18587,81 @@
       </p:sp>
       <p:sp>
         <p:nvSpPr>
-          <p:cNvPr id="106" name="MA"/>
+          <p:cNvPr id="150" name="BA"/>
+          <p:cNvSpPr/>
+          <p:nvPr/>
+        </p:nvSpPr>
+        <p:spPr>
+          <a:xfrm>
+            <a:off x="0" y="6807200"/>
+            <a:ext cx="12192000" cy="50800"/>
+          </a:xfrm>
+          <a:prstGeom prst="rect">
+            <a:avLst/>
+          </a:prstGeom>
+          <a:solidFill>
+            <a:srgbClr val="CC9900"/>
+          </a:solidFill>
+          <a:ln>
+            <a:noFill/>
+          </a:ln>
+        </p:spPr>
+        <p:txBody>
+          <a:bodyPr/>
+          <a:lstStyle/>
+          <a:p>
+            <a:endParaRPr lang="en-GB"/>
+          </a:p>
+        </p:txBody>
+      </p:sp>
+      <p:sp>
+        <p:nvSpPr>
+          <p:cNvPr id="104" name="Title"/>
+          <p:cNvSpPr/>
+          <p:nvPr/>
+        </p:nvSpPr>
+        <p:spPr>
+          <a:xfrm>
+            <a:off x="762000" y="533400"/>
+            <a:ext cx="9525000" cy="863600"/>
+          </a:xfrm>
+          <a:prstGeom prst="rect">
+            <a:avLst/>
+          </a:prstGeom>
+          <a:noFill/>
+          <a:ln>
+            <a:noFill/>
+          </a:ln>
+        </p:spPr>
+        <p:txBody>
+          <a:bodyPr wrap="square" lIns="0" tIns="0" rIns="0" bIns="0" anchor="b"/>
+          <a:lstStyle/>
+          <a:p>
+            <a:pPr algn="l"/>
+            <a:r>
+              <a:rPr lang="en-GB" sz="2800" b="1" dirty="0">
+                <a:solidFill>
+                  <a:srgbClr val="FFFFFF"/>
+                </a:solidFill>
+                <a:latin typeface="Raleway"/>
+              </a:rPr>
+              <a:t>Build Your </a:t>
+            </a:r>
+            <a:r>
+              <a:rPr lang="en-GB" sz="2800" b="1" dirty="0">
+                <a:solidFill>
+                  <a:srgbClr val="CC9900"/>
+                </a:solidFill>
+                <a:latin typeface="Raleway"/>
+              </a:rPr>
+              <a:t>Story</a:t>
+            </a:r>
+          </a:p>
+        </p:txBody>
+      </p:sp>
+      <p:sp>
+        <p:nvSpPr>
+          <p:cNvPr id="2" name="MA"/>
           <p:cNvSpPr/>
           <p:nvPr/>
         </p:nvSpPr>
@@ -18081,18 +18690,72 @@
       </p:sp>
       <p:sp>
         <p:nvSpPr>
-          <p:cNvPr id="110" name="Step0"/>
-          <p:cNvSpPr/>
-          <p:nvPr/>
-        </p:nvSpPr>
-        <p:spPr>
-          <a:xfrm>
-            <a:off x="762000" y="1968500"/>
-            <a:ext cx="3479800" cy="2667000"/>
+          <p:cNvPr id="106" name="Hero"/>
+          <p:cNvSpPr/>
+          <p:nvPr/>
+        </p:nvSpPr>
+        <p:spPr>
+          <a:xfrm>
+            <a:off x="762000" y="1841500"/>
+            <a:ext cx="10668000" cy="609600"/>
+          </a:xfrm>
+          <a:prstGeom prst="rect">
+            <a:avLst/>
+          </a:prstGeom>
+          <a:noFill/>
+          <a:ln>
+            <a:noFill/>
+          </a:ln>
+        </p:spPr>
+        <p:txBody>
+          <a:bodyPr wrap="square" lIns="0" tIns="0" rIns="0" bIns="0" anchor="t"/>
+          <a:lstStyle/>
+          <a:p>
+            <a:pPr algn="l"/>
+            <a:r>
+              <a:rPr lang="en-GB" sz="1600" dirty="0">
+                <a:solidFill>
+                  <a:srgbClr val="1A2744"/>
+                </a:solidFill>
+                <a:latin typeface="Source Sans Pro"/>
+              </a:rPr>
+              <a:t>Exploring the data is just the start. With </a:t>
+            </a:r>
+            <a:r>
+              <a:rPr lang="en-GB" sz="1600" b="1" dirty="0">
+                <a:solidFill>
+                  <a:srgbClr val="1A2744"/>
+                </a:solidFill>
+                <a:latin typeface="Source Sans Pro"/>
+              </a:rPr>
+              <a:t>pins</a:t>
+            </a:r>
+            <a:r>
+              <a:rPr lang="en-GB" sz="1600" dirty="0">
+                <a:solidFill>
+                  <a:srgbClr val="1A2744"/>
+                </a:solidFill>
+                <a:latin typeface="Source Sans Pro"/>
+              </a:rPr>
+              <a:t>, you capture the charts and tables that matter and arrange them into a narrative others can follow.</a:t>
+            </a:r>
+          </a:p>
+        </p:txBody>
+      </p:sp>
+      <p:sp>
+        <p:nvSpPr>
+          <p:cNvPr id="107" name="Step0"/>
+          <p:cNvSpPr/>
+          <p:nvPr/>
+        </p:nvSpPr>
+        <p:spPr>
+          <a:xfrm>
+            <a:off x="762000" y="2603500"/>
+            <a:ext cx="3302000" cy="2413000"/>
           </a:xfrm>
           <a:prstGeom prst="roundRect">
             <a:avLst>
-              <a:gd name="adj" fmla="val 6000"/>
+              <a:gd name="adj" fmla="val 4000"/>
             </a:avLst>
           </a:prstGeom>
           <a:solidFill>
@@ -18114,32 +18777,32 @@
       </p:sp>
       <p:sp>
         <p:nvSpPr>
-          <p:cNvPr id="111" name="SN0"/>
-          <p:cNvSpPr/>
-          <p:nvPr/>
-        </p:nvSpPr>
-        <p:spPr>
-          <a:xfrm>
-            <a:off x="2222500" y="2159000"/>
-            <a:ext cx="558800" cy="558800"/>
+          <p:cNvPr id="108" name="SN0"/>
+          <p:cNvSpPr/>
+          <p:nvPr/>
+        </p:nvSpPr>
+        <p:spPr>
+          <a:xfrm>
+            <a:off x="2159000" y="2781300"/>
+            <a:ext cx="508000" cy="508000"/>
           </a:xfrm>
           <a:prstGeom prst="ellipse">
             <a:avLst/>
           </a:prstGeom>
           <a:solidFill>
-            <a:srgbClr val="CC9900"/>
-          </a:solidFill>
-          <a:ln>
-            <a:noFill/>
-          </a:ln>
-        </p:spPr>
-        <p:txBody>
-          <a:bodyPr wrap="none" lIns="0" tIns="0" rIns="0" bIns="0" anchor="ctr"/>
+            <a:srgbClr val="4A90D9"/>
+          </a:solidFill>
+          <a:ln>
+            <a:noFill/>
+          </a:ln>
+        </p:spPr>
+        <p:txBody>
+          <a:bodyPr wrap="square" lIns="0" tIns="0" rIns="0" bIns="0" anchor="ctr"/>
           <a:lstStyle/>
           <a:p>
             <a:pPr algn="ctr"/>
             <a:r>
-              <a:rPr lang="en-GB" sz="2200" b="1" dirty="0">
+              <a:rPr lang="en-GB" sz="1800" b="1" dirty="0">
                 <a:solidFill>
                   <a:srgbClr val="FFFFFF"/>
                 </a:solidFill>
@@ -18152,14 +18815,14 @@
       </p:sp>
       <p:sp>
         <p:nvSpPr>
-          <p:cNvPr id="112" name="STxt0"/>
-          <p:cNvSpPr/>
-          <p:nvPr/>
-        </p:nvSpPr>
-        <p:spPr>
-          <a:xfrm>
-            <a:off x="952500" y="2857500"/>
-            <a:ext cx="3098800" cy="1587500"/>
+          <p:cNvPr id="109" name="STxt0"/>
+          <p:cNvSpPr/>
+          <p:nvPr/>
+        </p:nvSpPr>
+        <p:spPr>
+          <a:xfrm>
+            <a:off x="952500" y="3390900"/>
+            <a:ext cx="2921000" cy="1498600"/>
           </a:xfrm>
           <a:prstGeom prst="rect">
             <a:avLst/>
@@ -18175,11 +18838,11 @@
           <a:p>
             <a:pPr algn="ctr">
               <a:spcAft>
-                <a:spcPts val="400"/>
+                <a:spcPts val="300"/>
               </a:spcAft>
             </a:pPr>
             <a:r>
-              <a:rPr lang="en-GB" sz="2200" b="1" dirty="0">
+              <a:rPr lang="en-GB" sz="2000" b="1" dirty="0">
                 <a:solidFill>
                   <a:srgbClr val="1A2744"/>
                 </a:solidFill>
@@ -18191,67 +18854,60 @@
           <a:p>
             <a:pPr algn="ctr"/>
             <a:r>
-              <a:rPr lang="en-GB" sz="1400" dirty="0">
+              <a:rPr lang="en-GB" sz="1200" dirty="0">
                 <a:solidFill>
                   <a:srgbClr val="4A5568"/>
                 </a:solidFill>
                 <a:latin typeface="Source Sans Pro"/>
               </a:rPr>
-              <a:t>Browse tables, switch views, cut by any segment in the interactive report</a:t>
-            </a:r>
-          </a:p>
-        </p:txBody>
-      </p:sp>
-      <p:sp>
-        <p:nvSpPr>
-          <p:cNvPr id="140" name="Arr0"/>
-          <p:cNvSpPr/>
-          <p:nvPr/>
-        </p:nvSpPr>
-        <p:spPr>
-          <a:xfrm>
-            <a:off x="4241800" y="3048000"/>
-            <a:ext cx="254000" cy="381000"/>
-          </a:xfrm>
-          <a:prstGeom prst="rect">
-            <a:avLst/>
-          </a:prstGeom>
-          <a:noFill/>
-          <a:ln>
-            <a:noFill/>
-          </a:ln>
-        </p:spPr>
-        <p:txBody>
-          <a:bodyPr wrap="none" lIns="0" tIns="0" rIns="0" bIns="0" anchor="ctr"/>
-          <a:lstStyle/>
-          <a:p>
-            <a:pPr algn="ctr"/>
-            <a:r>
-              <a:rPr lang="en-GB" sz="2000" dirty="0">
-                <a:solidFill>
-                  <a:srgbClr val="CC9900"/>
-                </a:solidFill>
-                <a:latin typeface="Raleway"/>
-              </a:rPr>
-              <a:t>→</a:t>
-            </a:r>
-          </a:p>
-        </p:txBody>
-      </p:sp>
-      <p:sp>
-        <p:nvSpPr>
-          <p:cNvPr id="113" name="Step1"/>
-          <p:cNvSpPr/>
-          <p:nvPr/>
-        </p:nvSpPr>
-        <p:spPr>
-          <a:xfrm>
-            <a:off x="4495800" y="1968500"/>
-            <a:ext cx="3479800" cy="2667000"/>
+              <a:t>Browse the interactive report. Filter, compare, switch views — follow wherever the data leads you.</a:t>
+            </a:r>
+          </a:p>
+        </p:txBody>
+      </p:sp>
+      <p:sp>
+        <p:nvSpPr>
+          <p:cNvPr id="110" name="Arr0"/>
+          <p:cNvSpPr/>
+          <p:nvPr/>
+        </p:nvSpPr>
+        <p:spPr>
+          <a:xfrm>
+            <a:off x="4089400" y="3657600"/>
+            <a:ext cx="304800" cy="304800"/>
+          </a:xfrm>
+          <a:prstGeom prst="rightArrow">
+            <a:avLst/>
+          </a:prstGeom>
+          <a:solidFill>
+            <a:srgbClr val="CC9900"/>
+          </a:solidFill>
+          <a:ln>
+            <a:noFill/>
+          </a:ln>
+        </p:spPr>
+        <p:txBody>
+          <a:bodyPr/>
+          <a:lstStyle/>
+          <a:p>
+            <a:endParaRPr lang="en-GB"/>
+          </a:p>
+        </p:txBody>
+      </p:sp>
+      <p:sp>
+        <p:nvSpPr>
+          <p:cNvPr id="111" name="Step1"/>
+          <p:cNvSpPr/>
+          <p:nvPr/>
+        </p:nvSpPr>
+        <p:spPr>
+          <a:xfrm>
+            <a:off x="4445000" y="2603500"/>
+            <a:ext cx="3302000" cy="2413000"/>
           </a:xfrm>
           <a:prstGeom prst="roundRect">
             <a:avLst>
-              <a:gd name="adj" fmla="val 6000"/>
+              <a:gd name="adj" fmla="val 4000"/>
             </a:avLst>
           </a:prstGeom>
           <a:solidFill>
@@ -18273,32 +18929,32 @@
       </p:sp>
       <p:sp>
         <p:nvSpPr>
-          <p:cNvPr id="114" name="SN1"/>
-          <p:cNvSpPr/>
-          <p:nvPr/>
-        </p:nvSpPr>
-        <p:spPr>
-          <a:xfrm>
-            <a:off x="5956300" y="2159000"/>
-            <a:ext cx="558800" cy="558800"/>
+          <p:cNvPr id="112" name="SN1"/>
+          <p:cNvSpPr/>
+          <p:nvPr/>
+        </p:nvSpPr>
+        <p:spPr>
+          <a:xfrm>
+            <a:off x="5842000" y="2781300"/>
+            <a:ext cx="508000" cy="508000"/>
           </a:xfrm>
           <a:prstGeom prst="ellipse">
             <a:avLst/>
           </a:prstGeom>
           <a:solidFill>
-            <a:srgbClr val="4A90D9"/>
-          </a:solidFill>
-          <a:ln>
-            <a:noFill/>
-          </a:ln>
-        </p:spPr>
-        <p:txBody>
-          <a:bodyPr wrap="none" lIns="0" tIns="0" rIns="0" bIns="0" anchor="ctr"/>
+            <a:srgbClr val="CC9900"/>
+          </a:solidFill>
+          <a:ln>
+            <a:noFill/>
+          </a:ln>
+        </p:spPr>
+        <p:txBody>
+          <a:bodyPr wrap="square" lIns="0" tIns="0" rIns="0" bIns="0" anchor="ctr"/>
           <a:lstStyle/>
           <a:p>
             <a:pPr algn="ctr"/>
             <a:r>
-              <a:rPr lang="en-GB" sz="2200" b="1" dirty="0">
+              <a:rPr lang="en-GB" sz="1800" b="1" dirty="0">
                 <a:solidFill>
                   <a:srgbClr val="FFFFFF"/>
                 </a:solidFill>
@@ -18311,14 +18967,14 @@
       </p:sp>
       <p:sp>
         <p:nvSpPr>
-          <p:cNvPr id="115" name="STxt1"/>
-          <p:cNvSpPr/>
-          <p:nvPr/>
-        </p:nvSpPr>
-        <p:spPr>
-          <a:xfrm>
-            <a:off x="4686300" y="2857500"/>
-            <a:ext cx="3098800" cy="1587500"/>
+          <p:cNvPr id="113" name="STxt1"/>
+          <p:cNvSpPr/>
+          <p:nvPr/>
+        </p:nvSpPr>
+        <p:spPr>
+          <a:xfrm>
+            <a:off x="4635500" y="3390900"/>
+            <a:ext cx="2921000" cy="1498600"/>
           </a:xfrm>
           <a:prstGeom prst="rect">
             <a:avLst/>
@@ -18334,11 +18990,11 @@
           <a:p>
             <a:pPr algn="ctr">
               <a:spcAft>
-                <a:spcPts val="400"/>
+                <a:spcPts val="300"/>
               </a:spcAft>
             </a:pPr>
             <a:r>
-              <a:rPr lang="en-GB" sz="2200" b="1" dirty="0">
+              <a:rPr lang="en-GB" sz="2000" b="1" dirty="0">
                 <a:solidFill>
                   <a:srgbClr val="1A2744"/>
                 </a:solidFill>
@@ -18350,67 +19006,60 @@
           <a:p>
             <a:pPr algn="ctr"/>
             <a:r>
-              <a:rPr lang="en-GB" sz="1400" dirty="0">
+              <a:rPr lang="en-GB" sz="1200" dirty="0">
                 <a:solidFill>
                   <a:srgbClr val="4A5568"/>
                 </a:solidFill>
                 <a:latin typeface="Source Sans Pro"/>
               </a:rPr>
-              <a:t>Capture key findings with charts, commentary and images using pinned views</a:t>
-            </a:r>
-          </a:p>
-        </p:txBody>
-      </p:sp>
-      <p:sp>
-        <p:nvSpPr>
-          <p:cNvPr id="141" name="Arr1"/>
-          <p:cNvSpPr/>
-          <p:nvPr/>
-        </p:nvSpPr>
-        <p:spPr>
-          <a:xfrm>
-            <a:off x="7975600" y="3048000"/>
-            <a:ext cx="254000" cy="381000"/>
-          </a:xfrm>
-          <a:prstGeom prst="rect">
-            <a:avLst/>
-          </a:prstGeom>
-          <a:noFill/>
-          <a:ln>
-            <a:noFill/>
-          </a:ln>
-        </p:spPr>
-        <p:txBody>
-          <a:bodyPr wrap="none" lIns="0" tIns="0" rIns="0" bIns="0" anchor="ctr"/>
-          <a:lstStyle/>
-          <a:p>
-            <a:pPr algn="ctr"/>
-            <a:r>
-              <a:rPr lang="en-GB" sz="2000" dirty="0">
-                <a:solidFill>
-                  <a:srgbClr val="CC9900"/>
-                </a:solidFill>
-                <a:latin typeface="Raleway"/>
-              </a:rPr>
-              <a:t>→</a:t>
-            </a:r>
-          </a:p>
-        </p:txBody>
-      </p:sp>
-      <p:sp>
-        <p:nvSpPr>
-          <p:cNvPr id="116" name="Step2"/>
-          <p:cNvSpPr/>
-          <p:nvPr/>
-        </p:nvSpPr>
-        <p:spPr>
-          <a:xfrm>
-            <a:off x="8229600" y="1968500"/>
-            <a:ext cx="3479800" cy="2667000"/>
+              <a:t>Found something worth sharing? Pin it. Add your own commentary, title it, and build a sequence that tells a clear story.</a:t>
+            </a:r>
+          </a:p>
+        </p:txBody>
+      </p:sp>
+      <p:sp>
+        <p:nvSpPr>
+          <p:cNvPr id="114" name="Arr1"/>
+          <p:cNvSpPr/>
+          <p:nvPr/>
+        </p:nvSpPr>
+        <p:spPr>
+          <a:xfrm>
+            <a:off x="7772400" y="3657600"/>
+            <a:ext cx="304800" cy="304800"/>
+          </a:xfrm>
+          <a:prstGeom prst="rightArrow">
+            <a:avLst/>
+          </a:prstGeom>
+          <a:solidFill>
+            <a:srgbClr val="CC9900"/>
+          </a:solidFill>
+          <a:ln>
+            <a:noFill/>
+          </a:ln>
+        </p:spPr>
+        <p:txBody>
+          <a:bodyPr/>
+          <a:lstStyle/>
+          <a:p>
+            <a:endParaRPr lang="en-GB"/>
+          </a:p>
+        </p:txBody>
+      </p:sp>
+      <p:sp>
+        <p:nvSpPr>
+          <p:cNvPr id="115" name="Step2"/>
+          <p:cNvSpPr/>
+          <p:nvPr/>
+        </p:nvSpPr>
+        <p:spPr>
+          <a:xfrm>
+            <a:off x="8128000" y="2603500"/>
+            <a:ext cx="3302000" cy="2413000"/>
           </a:xfrm>
           <a:prstGeom prst="roundRect">
             <a:avLst>
-              <a:gd name="adj" fmla="val 6000"/>
+              <a:gd name="adj" fmla="val 4000"/>
             </a:avLst>
           </a:prstGeom>
           <a:solidFill>
@@ -18432,32 +19081,32 @@
       </p:sp>
       <p:sp>
         <p:nvSpPr>
-          <p:cNvPr id="117" name="SN2"/>
-          <p:cNvSpPr/>
-          <p:nvPr/>
-        </p:nvSpPr>
-        <p:spPr>
-          <a:xfrm>
-            <a:off x="9690100" y="2159000"/>
-            <a:ext cx="558800" cy="558800"/>
+          <p:cNvPr id="116" name="SN2"/>
+          <p:cNvSpPr/>
+          <p:nvPr/>
+        </p:nvSpPr>
+        <p:spPr>
+          <a:xfrm>
+            <a:off x="9525000" y="2781300"/>
+            <a:ext cx="508000" cy="508000"/>
           </a:xfrm>
           <a:prstGeom prst="ellipse">
             <a:avLst/>
           </a:prstGeom>
           <a:solidFill>
-            <a:srgbClr val="7C5CFC"/>
-          </a:solidFill>
-          <a:ln>
-            <a:noFill/>
-          </a:ln>
-        </p:spPr>
-        <p:txBody>
-          <a:bodyPr wrap="none" lIns="0" tIns="0" rIns="0" bIns="0" anchor="ctr"/>
+            <a:srgbClr val="E56B33"/>
+          </a:solidFill>
+          <a:ln>
+            <a:noFill/>
+          </a:ln>
+        </p:spPr>
+        <p:txBody>
+          <a:bodyPr wrap="square" lIns="0" tIns="0" rIns="0" bIns="0" anchor="ctr"/>
           <a:lstStyle/>
           <a:p>
             <a:pPr algn="ctr"/>
             <a:r>
-              <a:rPr lang="en-GB" sz="2200" b="1" dirty="0">
+              <a:rPr lang="en-GB" sz="1800" b="1" dirty="0">
                 <a:solidFill>
                   <a:srgbClr val="FFFFFF"/>
                 </a:solidFill>
@@ -18470,14 +19119,14 @@
       </p:sp>
       <p:sp>
         <p:nvSpPr>
-          <p:cNvPr id="118" name="STxt2"/>
-          <p:cNvSpPr/>
-          <p:nvPr/>
-        </p:nvSpPr>
-        <p:spPr>
-          <a:xfrm>
-            <a:off x="8420100" y="2857500"/>
-            <a:ext cx="3098800" cy="1587500"/>
+          <p:cNvPr id="117" name="STxt2"/>
+          <p:cNvSpPr/>
+          <p:nvPr/>
+        </p:nvSpPr>
+        <p:spPr>
+          <a:xfrm>
+            <a:off x="8318500" y="3390900"/>
+            <a:ext cx="2921000" cy="1498600"/>
           </a:xfrm>
           <a:prstGeom prst="rect">
             <a:avLst/>
@@ -18493,11 +19142,11 @@
           <a:p>
             <a:pPr algn="ctr">
               <a:spcAft>
-                <a:spcPts val="400"/>
+                <a:spcPts val="300"/>
               </a:spcAft>
             </a:pPr>
             <a:r>
-              <a:rPr lang="en-GB" sz="2200" b="1" dirty="0">
+              <a:rPr lang="en-GB" sz="2000" b="1" dirty="0">
                 <a:solidFill>
                   <a:srgbClr val="1A2744"/>
                 </a:solidFill>
@@ -18509,31 +19158,31 @@
           <a:p>
             <a:pPr algn="ctr"/>
             <a:r>
-              <a:rPr lang="en-GB" sz="1400" dirty="0">
+              <a:rPr lang="en-GB" sz="1200" dirty="0">
                 <a:solidFill>
                   <a:srgbClr val="4A5568"/>
                 </a:solidFill>
                 <a:latin typeface="Source Sans Pro"/>
               </a:rPr>
-              <a:t>Export pinned views to PowerPoint or PDF for stakeholder presentation</a:t>
-            </a:r>
-          </a:p>
-        </p:txBody>
-      </p:sp>
-      <p:sp>
-        <p:nvSpPr>
-          <p:cNvPr id="145" name="Call"/>
-          <p:cNvSpPr/>
-          <p:nvPr/>
-        </p:nvSpPr>
-        <p:spPr>
-          <a:xfrm>
-            <a:off x="762000" y="5016500"/>
-            <a:ext cx="10668000" cy="1079500"/>
+              <a:t>Walk stakeholders through your pinned narrative — inside the report itself, or export to PowerPoint or PDF.</a:t>
+            </a:r>
+          </a:p>
+        </p:txBody>
+      </p:sp>
+      <p:sp>
+        <p:nvSpPr>
+          <p:cNvPr id="118" name="Call"/>
+          <p:cNvSpPr/>
+          <p:nvPr/>
+        </p:nvSpPr>
+        <p:spPr>
+          <a:xfrm>
+            <a:off x="762000" y="5232400"/>
+            <a:ext cx="10668000" cy="889000"/>
           </a:xfrm>
           <a:prstGeom prst="roundRect">
             <a:avLst>
-              <a:gd name="adj" fmla="val 10000"/>
+              <a:gd name="adj" fmla="val 8000"/>
             </a:avLst>
           </a:prstGeom>
           <a:solidFill>
@@ -18544,7 +19193,7 @@
           </a:ln>
         </p:spPr>
         <p:txBody>
-          <a:bodyPr wrap="square" lIns="182880" tIns="45720" rIns="182880" bIns="45720" anchor="ctr"/>
+          <a:bodyPr wrap="square" lIns="72000" tIns="36000" rIns="72000" bIns="36000" anchor="ctr"/>
           <a:lstStyle/>
           <a:p>
             <a:pPr algn="ctr"/>
@@ -18555,44 +19204,27 @@
                 </a:solidFill>
                 <a:latin typeface="Source Sans Pro"/>
               </a:rPr>
-              <a:t>One environment for both exploration and presentation — no tool-switching required.</a:t>
-            </a:r>
-          </a:p>
-        </p:txBody>
-      </p:sp>
-      <p:sp>
-        <p:nvSpPr>
-          <p:cNvPr id="150" name="BA"/>
-          <p:cNvSpPr/>
-          <p:nvPr/>
-        </p:nvSpPr>
-        <p:spPr>
-          <a:xfrm>
-            <a:off x="0" y="6807200"/>
-            <a:ext cx="12192000" cy="50800"/>
-          </a:xfrm>
-          <a:prstGeom prst="rect">
-            <a:avLst/>
-          </a:prstGeom>
-          <a:solidFill>
-            <a:srgbClr val="CC9900"/>
-          </a:solidFill>
-          <a:ln>
-            <a:noFill/>
-          </a:ln>
-        </p:spPr>
-        <p:txBody>
-          <a:bodyPr/>
-          <a:lstStyle/>
-          <a:p>
-            <a:endParaRPr lang="en-GB"/>
+              <a:t>You don’t just receive results — you build the story you want to tell.</a:t>
+            </a:r>
+          </a:p>
+          <a:p>
+            <a:pPr algn="ctr"/>
+            <a:r>
+              <a:rPr lang="en-GB" sz="1200" dirty="0">
+                <a:solidFill>
+                  <a:srgbClr val="A0AEC0"/>
+                </a:solidFill>
+                <a:latin typeface="Source Sans Pro"/>
+              </a:rPr>
+              <a:t>One environment for exploration, narrative-building, and presentation — no tool-switching required.</a:t>
+            </a:r>
           </a:p>
         </p:txBody>
       </p:sp>
     </p:spTree>
     <p:extLst>
       <p:ext uri="{BB962C8B-B14F-4D97-AF65-F5344CB8AC3E}">
-        <p14:creationId xmlns:p14="http://schemas.microsoft.com/office/powerpoint/2010/main" val="1983053103"/>
+        <p14:creationId xmlns:p14="http://schemas.microsoft.com/office/powerpoint/2010/main" val="140500767"/>
       </p:ext>
     </p:extLst>
   </p:cSld>

</xml_diff>